<commit_message>
Updated Code after run
</commit_message>
<xml_diff>
--- a/docs/H-SIM_overview.pptx
+++ b/docs/H-SIM_overview.pptx
@@ -4,6 +4,9 @@
   <p:sldMasterIdLst>
     <p:sldMasterId id="2147483648" r:id="rId1"/>
   </p:sldMasterIdLst>
+  <p:notesMasterIdLst>
+    <p:notesMasterId r:id="rId14"/>
+  </p:notesMasterIdLst>
   <p:sldIdLst>
     <p:sldId id="256" r:id="rId2"/>
     <p:sldId id="257" r:id="rId3"/>
@@ -18,9 +21,6 @@
     <p:sldId id="266" r:id="rId12"/>
     <p:sldId id="267" r:id="rId13"/>
   </p:sldIdLst>
-  <p:notesMasterIdLst>
-    <p:notesMasterId r:id="rId14"/>
-  </p:notesMasterIdLst>
   <p:sldSz cx="12192000" cy="6858000"/>
   <p:notesSz cx="6858000" cy="12192000"/>
   <p:defaultTextStyle>
@@ -115,13 +115,143 @@
       </a:defRPr>
     </a:lvl9pPr>
   </p:defaultTextStyle>
+  <p:extLst>
+    <p:ext uri="{EFAFB233-063F-42B5-8137-9DF3F51BA10A}">
+      <p15:sldGuideLst xmlns:p15="http://schemas.microsoft.com/office/powerpoint/2012/main"/>
+    </p:ext>
+  </p:extLst>
 </p:presentation>
 </file>
 
+<file path=ppt/changesInfos/changesInfo1.xml><?xml version="1.0" encoding="utf-8"?>
+<pc:chgInfo xmlns:a="http://schemas.openxmlformats.org/drawingml/2006/main" xmlns:r="http://schemas.openxmlformats.org/officeDocument/2006/relationships" xmlns:ac="http://schemas.microsoft.com/office/drawing/2013/main/command" xmlns:pc="http://schemas.microsoft.com/office/powerpoint/2013/main/command">
+  <pc:docChgLst>
+    <pc:chgData name="Navin K. Twarakavi" userId="88581cf3-f0ba-465b-8190-5f31dc64834c" providerId="ADAL" clId="{76441A8B-B048-55DB-9C20-C6110DD5DDA9}"/>
+    <pc:docChg chg="custSel mod modSld modMainMaster">
+      <pc:chgData name="Navin K. Twarakavi" userId="88581cf3-f0ba-465b-8190-5f31dc64834c" providerId="ADAL" clId="{76441A8B-B048-55DB-9C20-C6110DD5DDA9}" dt="2026-08-04T02:03:31.957" v="36" actId="20577"/>
+      <pc:docMkLst>
+        <pc:docMk/>
+      </pc:docMkLst>
+      <pc:sldChg chg="delSp mod">
+        <pc:chgData name="Navin K. Twarakavi" userId="88581cf3-f0ba-465b-8190-5f31dc64834c" providerId="ADAL" clId="{76441A8B-B048-55DB-9C20-C6110DD5DDA9}" dt="2026-08-04T02:02:45.189" v="5" actId="478"/>
+        <pc:sldMkLst>
+          <pc:docMk/>
+          <pc:sldMk cId="0" sldId="256"/>
+        </pc:sldMkLst>
+        <pc:spChg chg="del">
+          <ac:chgData name="Navin K. Twarakavi" userId="88581cf3-f0ba-465b-8190-5f31dc64834c" providerId="ADAL" clId="{76441A8B-B048-55DB-9C20-C6110DD5DDA9}" dt="2026-08-04T02:02:31.869" v="0" actId="478"/>
+          <ac:spMkLst>
+            <pc:docMk/>
+            <pc:sldMk cId="0" sldId="256"/>
+            <ac:spMk id="2" creationId="{00000000-0000-0000-0000-000000000000}"/>
+          </ac:spMkLst>
+        </pc:spChg>
+        <pc:spChg chg="del">
+          <ac:chgData name="Navin K. Twarakavi" userId="88581cf3-f0ba-465b-8190-5f31dc64834c" providerId="ADAL" clId="{76441A8B-B048-55DB-9C20-C6110DD5DDA9}" dt="2026-08-04T02:02:33.429" v="1" actId="478"/>
+          <ac:spMkLst>
+            <pc:docMk/>
+            <pc:sldMk cId="0" sldId="256"/>
+            <ac:spMk id="3" creationId="{00000000-0000-0000-0000-000000000000}"/>
+          </ac:spMkLst>
+        </pc:spChg>
+        <pc:spChg chg="del">
+          <ac:chgData name="Navin K. Twarakavi" userId="88581cf3-f0ba-465b-8190-5f31dc64834c" providerId="ADAL" clId="{76441A8B-B048-55DB-9C20-C6110DD5DDA9}" dt="2026-08-04T02:02:45.189" v="5" actId="478"/>
+          <ac:spMkLst>
+            <pc:docMk/>
+            <pc:sldMk cId="0" sldId="256"/>
+            <ac:spMk id="6" creationId="{00000000-0000-0000-0000-000000000000}"/>
+          </ac:spMkLst>
+        </pc:spChg>
+        <pc:spChg chg="del">
+          <ac:chgData name="Navin K. Twarakavi" userId="88581cf3-f0ba-465b-8190-5f31dc64834c" providerId="ADAL" clId="{76441A8B-B048-55DB-9C20-C6110DD5DDA9}" dt="2026-08-04T02:02:39.194" v="4" actId="478"/>
+          <ac:spMkLst>
+            <pc:docMk/>
+            <pc:sldMk cId="0" sldId="256"/>
+            <ac:spMk id="7" creationId="{00000000-0000-0000-0000-000000000000}"/>
+          </ac:spMkLst>
+        </pc:spChg>
+        <pc:spChg chg="del">
+          <ac:chgData name="Navin K. Twarakavi" userId="88581cf3-f0ba-465b-8190-5f31dc64834c" providerId="ADAL" clId="{76441A8B-B048-55DB-9C20-C6110DD5DDA9}" dt="2026-08-04T02:02:39.194" v="4" actId="478"/>
+          <ac:spMkLst>
+            <pc:docMk/>
+            <pc:sldMk cId="0" sldId="256"/>
+            <ac:spMk id="8" creationId="{00000000-0000-0000-0000-000000000000}"/>
+          </ac:spMkLst>
+        </pc:spChg>
+        <pc:spChg chg="del">
+          <ac:chgData name="Navin K. Twarakavi" userId="88581cf3-f0ba-465b-8190-5f31dc64834c" providerId="ADAL" clId="{76441A8B-B048-55DB-9C20-C6110DD5DDA9}" dt="2026-08-04T02:02:39.194" v="4" actId="478"/>
+          <ac:spMkLst>
+            <pc:docMk/>
+            <pc:sldMk cId="0" sldId="256"/>
+            <ac:spMk id="9" creationId="{00000000-0000-0000-0000-000000000000}"/>
+          </ac:spMkLst>
+        </pc:spChg>
+      </pc:sldChg>
+      <pc:sldChg chg="delSp modSp mod">
+        <pc:chgData name="Navin K. Twarakavi" userId="88581cf3-f0ba-465b-8190-5f31dc64834c" providerId="ADAL" clId="{76441A8B-B048-55DB-9C20-C6110DD5DDA9}" dt="2026-08-04T02:03:31.957" v="36" actId="20577"/>
+        <pc:sldMkLst>
+          <pc:docMk/>
+          <pc:sldMk cId="0" sldId="257"/>
+        </pc:sldMkLst>
+        <pc:spChg chg="mod">
+          <ac:chgData name="Navin K. Twarakavi" userId="88581cf3-f0ba-465b-8190-5f31dc64834c" providerId="ADAL" clId="{76441A8B-B048-55DB-9C20-C6110DD5DDA9}" dt="2026-08-04T02:03:31.957" v="36" actId="20577"/>
+          <ac:spMkLst>
+            <pc:docMk/>
+            <pc:sldMk cId="0" sldId="257"/>
+            <ac:spMk id="2" creationId="{00000000-0000-0000-0000-000000000000}"/>
+          </ac:spMkLst>
+        </pc:spChg>
+        <pc:spChg chg="del">
+          <ac:chgData name="Navin K. Twarakavi" userId="88581cf3-f0ba-465b-8190-5f31dc64834c" providerId="ADAL" clId="{76441A8B-B048-55DB-9C20-C6110DD5DDA9}" dt="2026-08-04T02:03:08.986" v="6" actId="478"/>
+          <ac:spMkLst>
+            <pc:docMk/>
+            <pc:sldMk cId="0" sldId="257"/>
+            <ac:spMk id="16" creationId="{00000000-0000-0000-0000-000000000000}"/>
+          </ac:spMkLst>
+        </pc:spChg>
+        <pc:spChg chg="del">
+          <ac:chgData name="Navin K. Twarakavi" userId="88581cf3-f0ba-465b-8190-5f31dc64834c" providerId="ADAL" clId="{76441A8B-B048-55DB-9C20-C6110DD5DDA9}" dt="2026-08-04T02:03:13.471" v="7" actId="478"/>
+          <ac:spMkLst>
+            <pc:docMk/>
+            <pc:sldMk cId="0" sldId="257"/>
+            <ac:spMk id="17" creationId="{00000000-0000-0000-0000-000000000000}"/>
+          </ac:spMkLst>
+        </pc:spChg>
+        <pc:spChg chg="del">
+          <ac:chgData name="Navin K. Twarakavi" userId="88581cf3-f0ba-465b-8190-5f31dc64834c" providerId="ADAL" clId="{76441A8B-B048-55DB-9C20-C6110DD5DDA9}" dt="2026-08-04T02:03:13.471" v="7" actId="478"/>
+          <ac:spMkLst>
+            <pc:docMk/>
+            <pc:sldMk cId="0" sldId="257"/>
+            <ac:spMk id="18" creationId="{00000000-0000-0000-0000-000000000000}"/>
+          </ac:spMkLst>
+        </pc:spChg>
+      </pc:sldChg>
+      <pc:sldMasterChg chg="addSp mod">
+        <pc:chgData name="Navin K. Twarakavi" userId="88581cf3-f0ba-465b-8190-5f31dc64834c" providerId="ADAL" clId="{76441A8B-B048-55DB-9C20-C6110DD5DDA9}" dt="2026-08-04T02:02:36.768" v="2" actId="33475"/>
+        <pc:sldMasterMkLst>
+          <pc:docMk/>
+          <pc:sldMasterMk cId="0" sldId="2147483648"/>
+        </pc:sldMasterMkLst>
+        <pc:spChg chg="add">
+          <ac:chgData name="Navin K. Twarakavi" userId="88581cf3-f0ba-465b-8190-5f31dc64834c" providerId="ADAL" clId="{76441A8B-B048-55DB-9C20-C6110DD5DDA9}" dt="2026-08-04T02:02:36.768" v="2" actId="33475"/>
+          <ac:spMkLst>
+            <pc:docMk/>
+            <pc:sldMasterMk cId="0" sldId="2147483648"/>
+            <ac:spMk id="3" creationId="{833115E1-F553-021E-8B54-BCD158AA0EE4}"/>
+          </ac:spMkLst>
+        </pc:spChg>
+      </pc:sldMasterChg>
+    </pc:docChg>
+  </pc:docChgLst>
+</pc:chgInfo>
+</file>
+
 <file path=ppt/charts/chart1.xml><?xml version="1.0" encoding="utf-8"?>
-<c:chartSpace xmlns:c="http://schemas.openxmlformats.org/drawingml/2006/chart" xmlns:a="http://schemas.openxmlformats.org/drawingml/2006/main" xmlns:r="http://schemas.openxmlformats.org/officeDocument/2006/relationships">
+<c:chartSpace xmlns:c="http://schemas.openxmlformats.org/drawingml/2006/chart" xmlns:a="http://schemas.openxmlformats.org/drawingml/2006/main" xmlns:r="http://schemas.openxmlformats.org/officeDocument/2006/relationships" xmlns:c16r2="http://schemas.microsoft.com/office/drawing/2015/06/chart">
   <c:date1904 val="0"/>
+  <c:lang val="en-US"/>
   <c:roundedCorners val="1"/>
+  <c:style val="2"/>
   <c:chart>
     <c:title>
       <c:tx>
@@ -149,7 +279,6 @@
           </a:p>
         </c:rich>
       </c:tx>
-      <c:layout/>
       <c:overlay val="0"/>
     </c:title>
     <c:autoTitleDeleted val="0"/>
@@ -182,18 +311,26 @@
           <c:invertIfNegative val="0"/>
           <c:dLbls>
             <c:numFmt formatCode="0.000" sourceLinked="0"/>
+            <c:spPr>
+              <a:noFill/>
+              <a:ln>
+                <a:noFill/>
+              </a:ln>
+              <a:effectLst/>
+            </c:spPr>
             <c:txPr>
               <a:bodyPr/>
               <a:lstStyle/>
               <a:p>
                 <a:pPr>
-                  <a:defRPr b="0" i="0" strike="noStrike" sz="1100" u="none">
+                  <a:defRPr sz="1100" b="0" i="0" u="none" strike="noStrike">
                     <a:solidFill>
                       <a:srgbClr val="101418"/>
                     </a:solidFill>
                     <a:latin typeface="Arial"/>
                   </a:defRPr>
                 </a:pPr>
+                <a:endParaRPr lang="en-US"/>
               </a:p>
             </c:txPr>
             <c:showLegendKey val="0"/>
@@ -203,25 +340,28 @@
             <c:showPercent val="0"/>
             <c:showBubbleSize val="0"/>
             <c:showLeaderLines val="0"/>
+            <c:extLst>
+              <c:ext xmlns:c15="http://schemas.microsoft.com/office/drawing/2012/chart" uri="{CE6537A1-D6FC-4f65-9D91-7224C49458BB}">
+                <c15:showLeaderLines val="0"/>
+              </c:ext>
+            </c:extLst>
           </c:dLbls>
           <c:cat>
-            <c:multiLvlStrRef>
+            <c:strRef>
               <c:f>Sheet1!$A$2:$A$4</c:f>
-              <c:multiLvlStrCache>
+              <c:strCache>
                 <c:ptCount val="3"/>
-                <c:lvl>
-                  <c:pt idx="0">
-                    <c:v>250 m</c:v>
-                  </c:pt>
-                  <c:pt idx="1">
-                    <c:v>90 m</c:v>
-                  </c:pt>
-                  <c:pt idx="2">
-                    <c:v>30 m</c:v>
-                  </c:pt>
-                </c:lvl>
-              </c:multiLvlStrCache>
-            </c:multiLvlStrRef>
+                <c:pt idx="0">
+                  <c:v>250 m</c:v>
+                </c:pt>
+                <c:pt idx="1">
+                  <c:v>90 m</c:v>
+                </c:pt>
+                <c:pt idx="2">
+                  <c:v>30 m</c:v>
+                </c:pt>
+              </c:strCache>
+            </c:strRef>
           </c:cat>
           <c:val>
             <c:numRef>
@@ -230,47 +370,34 @@
                 <c:formatCode>General</c:formatCode>
                 <c:ptCount val="3"/>
                 <c:pt idx="0">
-                  <c:v>0.7281</c:v>
+                  <c:v>0.72809999999999997</c:v>
                 </c:pt>
                 <c:pt idx="1">
-                  <c:v>0.8059</c:v>
+                  <c:v>0.80589999999999995</c:v>
                 </c:pt>
                 <c:pt idx="2">
-                  <c:v>0.8156</c:v>
+                  <c:v>0.81559999999999999</c:v>
                 </c:pt>
               </c:numCache>
             </c:numRef>
           </c:val>
+          <c:extLst>
+            <c:ext xmlns:c16="http://schemas.microsoft.com/office/drawing/2014/chart" uri="{C3380CC4-5D6E-409C-BE32-E72D297353CC}">
+              <c16:uniqueId val="{00000000-2A32-4B44-A237-B10A81DBCF7C}"/>
+            </c:ext>
+          </c:extLst>
         </c:ser>
         <c:dLbls>
-          <c:numFmt formatCode="0.000" sourceLinked="0"/>
-          <c:txPr>
-            <a:bodyPr/>
-            <a:lstStyle/>
-            <a:p>
-              <a:pPr>
-                <a:defRPr b="0" i="0" strike="noStrike" sz="1100" u="none">
-                  <a:solidFill>
-                    <a:srgbClr val="101418"/>
-                  </a:solidFill>
-                  <a:latin typeface="Arial"/>
-                </a:defRPr>
-              </a:pPr>
-            </a:p>
-          </c:txPr>
           <c:showLegendKey val="0"/>
           <c:showVal val="1"/>
           <c:showCatName val="0"/>
           <c:showSerName val="0"/>
           <c:showPercent val="0"/>
           <c:showBubbleSize val="0"/>
-          <c:showLeaderLines val="0"/>
         </c:dLbls>
         <c:gapWidth val="150"/>
-        <c:overlap val="0"/>
         <c:axId val="2094734554"/>
         <c:axId val="2094734552"/>
-        <c:axId val="2094734556"/>
       </c:barChart>
       <c:catAx>
         <c:axId val="2094734554"/>
@@ -311,6 +438,7 @@
         <c:crosses val="autoZero"/>
         <c:auto val="1"/>
         <c:lblAlgn val="ctr"/>
+        <c:lblOffset val="100"/>
         <c:noMultiLvlLbl val="1"/>
       </c:catAx>
       <c:valAx>
@@ -376,6 +504,7 @@
     </c:plotArea>
     <c:plotVisOnly val="1"/>
     <c:dispBlanksAs val="span"/>
+    <c:showDLblsOverMax val="1"/>
   </c:chart>
   <c:spPr>
     <a:noFill/>
@@ -412,234 +541,10 @@
           <a:chExt cx="0" cy="0"/>
         </a:xfrm>
       </p:grpSpPr>
-      <p:sp>
-        <p:nvSpPr>
-          <p:cNvPr id="2" name="Header Placeholder 1"/>
-          <p:cNvSpPr>
-            <a:spLocks noGrp="1"/>
-          </p:cNvSpPr>
-          <p:nvPr>
-            <p:ph type="hdr" sz="quarter"/>
-          </p:nvPr>
-        </p:nvSpPr>
-        <p:spPr>
-          <a:xfrm>
-            <a:off x="0" y="0"/>
-            <a:ext cx="2971800" cy="458788"/>
-          </a:xfrm>
-          <a:prstGeom prst="rect">
-            <a:avLst/>
-          </a:prstGeom>
-        </p:spPr>
-        <p:txBody>
-          <a:bodyPr vert="horz" lIns="91440" tIns="45720" rIns="91440" bIns="45720" rtlCol="0"/>
-          <a:lstStyle>
-            <a:lvl1pPr algn="l">
-              <a:defRPr sz="1200"/>
-            </a:lvl1pPr>
-          </a:lstStyle>
-          <a:p>
-            <a:endParaRPr lang="en-US"/>
-          </a:p>
-        </p:txBody>
-      </p:sp>
-      <p:sp>
-        <p:nvSpPr>
-          <p:cNvPr id="3" name="Date Placeholder 2"/>
-          <p:cNvSpPr>
-            <a:spLocks noGrp="1"/>
-          </p:cNvSpPr>
-          <p:nvPr>
-            <p:ph type="dt" idx="1"/>
-          </p:nvPr>
-        </p:nvSpPr>
-        <p:spPr>
-          <a:xfrm>
-            <a:off x="3884613" y="0"/>
-            <a:ext cx="2971800" cy="458788"/>
-          </a:xfrm>
-          <a:prstGeom prst="rect">
-            <a:avLst/>
-          </a:prstGeom>
-        </p:spPr>
-        <p:txBody>
-          <a:bodyPr vert="horz" lIns="91440" tIns="45720" rIns="91440" bIns="45720" rtlCol="0"/>
-          <a:lstStyle>
-            <a:lvl1pPr algn="r">
-              <a:defRPr sz="1200"/>
-            </a:lvl1pPr>
-          </a:lstStyle>
-          <a:p>
-            <a:fld id="{5282F153-3F37-0F45-9E97-73ACFA13230C}" type="datetimeFigureOut">
-              <a:rPr lang="en-US"/>
-              <a:t>7/23/19</a:t>
-            </a:fld>
-            <a:endParaRPr lang="en-US"/>
-          </a:p>
-        </p:txBody>
-      </p:sp>
-      <p:sp>
-        <p:nvSpPr>
-          <p:cNvPr id="4" name="Slide Image Placeholder 3"/>
-          <p:cNvSpPr>
-            <a:spLocks noGrp="1" noRot="1" noChangeAspect="1"/>
-          </p:cNvSpPr>
-          <p:nvPr>
-            <p:ph type="sldImg" idx="2"/>
-          </p:nvPr>
-        </p:nvSpPr>
-        <p:spPr>
-          <a:xfrm>
-            <a:off x="685800" y="1143000"/>
-            <a:ext cx="5486400" cy="3086100"/>
-          </a:xfrm>
-          <a:prstGeom prst="rect">
-            <a:avLst/>
-          </a:prstGeom>
-          <a:noFill/>
-          <a:ln w="12700">
-            <a:solidFill>
-              <a:prstClr val="black"/>
-            </a:solidFill>
-          </a:ln>
-        </p:spPr>
-        <p:txBody>
-          <a:bodyPr vert="horz" lIns="91440" tIns="45720" rIns="91440" bIns="45720" rtlCol="0" anchor="ctr"/>
-          <a:lstStyle/>
-          <a:p>
-            <a:endParaRPr lang="en-US"/>
-          </a:p>
-        </p:txBody>
-      </p:sp>
-      <p:sp>
-        <p:nvSpPr>
-          <p:cNvPr id="5" name="Notes Placeholder 4"/>
-          <p:cNvSpPr>
-            <a:spLocks noGrp="1"/>
-          </p:cNvSpPr>
-          <p:nvPr>
-            <p:ph type="body" sz="quarter" idx="3"/>
-          </p:nvPr>
-        </p:nvSpPr>
-        <p:spPr>
-          <a:xfrm>
-            <a:off x="685800" y="4400550"/>
-            <a:ext cx="5486400" cy="3600450"/>
-          </a:xfrm>
-          <a:prstGeom prst="rect">
-            <a:avLst/>
-          </a:prstGeom>
-        </p:spPr>
-        <p:txBody>
-          <a:bodyPr vert="horz" lIns="91440" tIns="45720" rIns="91440" bIns="45720" rtlCol="0"/>
-          <a:lstStyle/>
-          <a:p>
-            <a:pPr lvl="0"/>
-            <a:r>
-              <a:rPr lang="en-US"/>
-              <a:t>Click to edit Master text styles</a:t>
-            </a:r>
-          </a:p>
-          <a:p>
-            <a:pPr lvl="1"/>
-            <a:r>
-              <a:rPr lang="en-US"/>
-              <a:t>Second level</a:t>
-            </a:r>
-          </a:p>
-          <a:p>
-            <a:pPr lvl="2"/>
-            <a:r>
-              <a:rPr lang="en-US"/>
-              <a:t>Third level</a:t>
-            </a:r>
-          </a:p>
-          <a:p>
-            <a:pPr lvl="3"/>
-            <a:r>
-              <a:rPr lang="en-US"/>
-              <a:t>Fourth level</a:t>
-            </a:r>
-          </a:p>
-          <a:p>
-            <a:pPr lvl="4"/>
-            <a:r>
-              <a:rPr lang="en-US"/>
-              <a:t>Fifth level</a:t>
-            </a:r>
-          </a:p>
-        </p:txBody>
-      </p:sp>
-      <p:sp>
-        <p:nvSpPr>
-          <p:cNvPr id="6" name="Footer Placeholder 5"/>
-          <p:cNvSpPr>
-            <a:spLocks noGrp="1"/>
-          </p:cNvSpPr>
-          <p:nvPr>
-            <p:ph type="ftr" sz="quarter" idx="4"/>
-          </p:nvPr>
-        </p:nvSpPr>
-        <p:spPr>
-          <a:xfrm>
-            <a:off x="0" y="8685213"/>
-            <a:ext cx="2971800" cy="458787"/>
-          </a:xfrm>
-          <a:prstGeom prst="rect">
-            <a:avLst/>
-          </a:prstGeom>
-        </p:spPr>
-        <p:txBody>
-          <a:bodyPr vert="horz" lIns="91440" tIns="45720" rIns="91440" bIns="45720" rtlCol="0" anchor="b"/>
-          <a:lstStyle>
-            <a:lvl1pPr algn="l">
-              <a:defRPr sz="1200"/>
-            </a:lvl1pPr>
-          </a:lstStyle>
-          <a:p>
-            <a:endParaRPr lang="en-US"/>
-          </a:p>
-        </p:txBody>
-      </p:sp>
-      <p:sp>
-        <p:nvSpPr>
-          <p:cNvPr id="7" name="Slide Number Placeholder 6"/>
-          <p:cNvSpPr>
-            <a:spLocks noGrp="1"/>
-          </p:cNvSpPr>
-          <p:nvPr>
-            <p:ph type="sldNum" sz="quarter" idx="5"/>
-          </p:nvPr>
-        </p:nvSpPr>
-        <p:spPr>
-          <a:xfrm>
-            <a:off x="3884613" y="8685213"/>
-            <a:ext cx="2971800" cy="458787"/>
-          </a:xfrm>
-          <a:prstGeom prst="rect">
-            <a:avLst/>
-          </a:prstGeom>
-        </p:spPr>
-        <p:txBody>
-          <a:bodyPr vert="horz" lIns="91440" tIns="45720" rIns="91440" bIns="45720" rtlCol="0" anchor="b"/>
-          <a:lstStyle>
-            <a:lvl1pPr algn="r">
-              <a:defRPr sz="1200"/>
-            </a:lvl1pPr>
-          </a:lstStyle>
-          <a:p>
-            <a:fld id="{CE5E9CC1-C706-0F49-92D6-E571CC5EEA8F}" type="slidenum">
-              <a:rPr lang="en-US"/>
-              <a:t>‹#›</a:t>
-            </a:fld>
-            <a:endParaRPr lang="en-US"/>
-          </a:p>
-        </p:txBody>
-      </p:sp>
     </p:spTree>
     <p:extLst>
       <p:ext uri="{BB962C8B-B14F-4D97-AF65-F5344CB8AC3E}">
-        <p14:creationId xmlns:p14="http://schemas.microsoft.com/office/powerpoint/2010/main" val="1024086991"/>
+        <p14:creationId xmlns:p14="http://schemas.microsoft.com/office/powerpoint/2010/main" val="1669642186"/>
       </p:ext>
     </p:extLst>
   </p:cSld>
@@ -787,7 +692,6 @@
               <a:rPr lang="en-US" dirty="0"/>
               <a:t>H-SIM answers one question for eight countries: of all the places people and roads sit under Himalayan slopes, which deserve attention first? One physically based model, one product, honestly labelled. The tagline is the app's legend: colour encodes exposure, shape encodes how a road fails.</a:t>
             </a:r>
-            <a:endParaRPr lang="en-US" dirty="0"/>
           </a:p>
         </p:txBody>
       </p:sp>
@@ -875,7 +779,6 @@
               <a:rPr lang="en-US" dirty="0"/>
               <a:t>These four sentences are the difference between a defensible screen and an over-claim. They appear in the README, in the app footer, and in every summary JSON's note field — deliberately impossible to strip from the product.</a:t>
             </a:r>
-            <a:endParaRPr lang="en-US" dirty="0"/>
           </a:p>
         </p:txBody>
       </p:sp>
@@ -963,7 +866,6 @@
               <a:rPr lang="en-US" dirty="0"/>
               <a:t>Operationally simple by design: one config file per product, one command per stage, resumable everywhere. The 'h-sim' shorthand stands for 'python -m h_sim.cli'.</a:t>
             </a:r>
-            <a:endParaRPr lang="en-US" dirty="0"/>
           </a:p>
         </p:txBody>
       </p:sp>
@@ -1051,7 +953,6 @@
               <a:rPr lang="en-US" dirty="0"/>
               <a:t>The roadmap follows the same rule as everything shipped: implemented, tested, and gated on a held-out number. Questions welcome — every figure in this deck traces to a script and a results JSON in the repository.</a:t>
             </a:r>
-            <a:endParaRPr lang="en-US" dirty="0"/>
           </a:p>
         </p:txBody>
       </p:sp>
@@ -1139,7 +1040,6 @@
               <a:rPr lang="en-US" dirty="0"/>
               <a:t>For management: the deliverable is one HTML file that opens in any browser. 95 provinces ranked by how much of their ground the model calls unstable, with the human stakes beside each. Selecting a province embeds its full map. Everything else in this deck explains why those numbers can be trusted, and exactly how far.</a:t>
             </a:r>
-            <a:endParaRPr lang="en-US" dirty="0"/>
           </a:p>
         </p:txBody>
       </p:sp>
@@ -1227,7 +1127,6 @@
               <a:rPr lang="en-US" dirty="0"/>
               <a:t>For engineers: SINMAP closes the infinite-slope equation with a steady-state wetness term. Pseudo-static seismic loading extends it to earthquake scenarios; CMIP6 recharge scaling extends it to 2060. The honest part: parameters are fitted ranges, not lab values, and the map is the probability over those ranges — relative by construction.</a:t>
             </a:r>
-            <a:endParaRPr lang="en-US" dirty="0"/>
           </a:p>
         </p:txBody>
       </p:sp>
@@ -1315,7 +1214,6 @@
               <a:rPr lang="en-US" dirty="0"/>
               <a:t>Each numbered step is one CLI command; the README's Quick Reference lists them in order. The design assumption is that something always interrupts a multi-day sweep, so resumability is a first-class feature, and cheap refresh paths exist for display-only changes.</a:t>
             </a:r>
-            <a:endParaRPr lang="en-US" dirty="0"/>
           </a:p>
         </p:txBody>
       </p:sp>
@@ -1403,7 +1301,6 @@
               <a:rPr lang="en-US" dirty="0"/>
               <a:t>Every claim traces to a script in analysis/ and a JSON of results. The failure case is presented with the successes: on Shimla's road-cut inventory the model inverts, which is why the app never pretends to score cut-slopes — it flags them as geometry instead.</a:t>
             </a:r>
-            <a:endParaRPr lang="en-US" dirty="0"/>
           </a:p>
         </p:txBody>
       </p:sp>
@@ -1491,7 +1388,6 @@
               <a:rPr lang="en-US" dirty="0"/>
               <a:t>Four upgrades to how assets are scored, all visible in the app's popups. The clip fixed a real defect — Meghalaya's map used to show Bangladeshi villages floating outside the border. Footprints, sector and supply are literature-grounded: GHS-BUILT can replace the disc radii behind the same interface when we add the dataset.</a:t>
             </a:r>
-            <a:endParaRPr lang="en-US" dirty="0"/>
           </a:p>
         </p:txBody>
       </p:sp>
@@ -1579,7 +1475,6 @@
               <a:rPr lang="en-US" dirty="0"/>
               <a:t>This is the display rule the whole app teaches: colour = exposure, shape = mechanism. Two of the three mechanisms are honest geometric flags rather than model output, and the app's legend says so — that honesty is what makes the map defensible in front of a road department.</a:t>
             </a:r>
-            <a:endParaRPr lang="en-US" dirty="0"/>
           </a:p>
         </p:txBody>
       </p:sp>
@@ -1667,7 +1562,6 @@
               <a:rPr lang="en-US" dirty="0"/>
               <a:t>Both features are fully implemented, unit-tested on constructed terrain, and OFF. The experiment scripts are the switches; each prints an explicit ADOPT or NULL verdict. This is the repository's core epistemics: physically motivated is not the same as measurably better.</a:t>
             </a:r>
-            <a:endParaRPr lang="en-US" dirty="0"/>
           </a:p>
         </p:txBody>
       </p:sp>
@@ -1755,7 +1649,6 @@
               <a:rPr lang="en-US" dirty="0"/>
               <a:t>The same page serves three audiences. A collapsible 'How to read this map' explainer sits at the top of every province sidebar and makes the encoding teachable in one breath: colour is exposure, shape is mechanism, scenarios re-play the terrain. Works offline from a folder; a MapTiler key upgrades the basemap, a keyless CARTO fallback keeps it working without one.</a:t>
             </a:r>
-            <a:endParaRPr lang="en-US" dirty="0"/>
           </a:p>
         </p:txBody>
       </p:sp>
@@ -1828,6 +1721,11 @@
 <file path=ppt/slideMasters/slideMaster1.xml><?xml version="1.0" encoding="utf-8"?>
 <p:sldMaster xmlns:a="http://schemas.openxmlformats.org/drawingml/2006/main" xmlns:r="http://schemas.openxmlformats.org/officeDocument/2006/relationships" xmlns:p="http://schemas.openxmlformats.org/presentationml/2006/main">
   <p:cSld>
+    <p:bg>
+      <p:bgRef idx="1001">
+        <a:schemeClr val="bg1"/>
+      </p:bgRef>
+    </p:bg>
     <p:spTree>
       <p:nvGrpSpPr>
         <p:cNvPr id="1" name=""/>
@@ -1842,6 +1740,54 @@
           <a:chExt cx="0" cy="0"/>
         </a:xfrm>
       </p:grpSpPr>
+      <p:sp>
+        <p:nvSpPr>
+          <p:cNvPr id="3" name="TextBox 2">
+            <a:extLst>
+              <a:ext uri="{FF2B5EF4-FFF2-40B4-BE49-F238E27FC236}">
+                <a16:creationId xmlns:a16="http://schemas.microsoft.com/office/drawing/2014/main" id="{833115E1-F553-021E-8B54-BCD158AA0EE4}"/>
+              </a:ext>
+            </a:extLst>
+          </p:cNvPr>
+          <p:cNvSpPr txBox="1"/>
+          <p:nvPr userDrawn="1">
+            <p:extLst>
+              <p:ext uri="{1162E1C5-73C7-4A58-AE30-91384D911F3F}">
+                <p184:classification xmlns:p184="http://schemas.microsoft.com/office/powerpoint/2018/4/main" val="ftr"/>
+              </p:ext>
+            </p:extLst>
+          </p:nvPr>
+        </p:nvSpPr>
+        <p:spPr>
+          <a:xfrm>
+            <a:off x="3224213" y="6672580"/>
+            <a:ext cx="5764212" cy="121920"/>
+          </a:xfrm>
+          <a:prstGeom prst="rect">
+            <a:avLst/>
+          </a:prstGeom>
+        </p:spPr>
+        <p:txBody>
+          <a:bodyPr horzOverflow="overflow" lIns="0" tIns="0" rIns="0" bIns="0">
+            <a:spAutoFit/>
+          </a:bodyPr>
+          <a:lstStyle/>
+          <a:p>
+            <a:pPr algn="l"/>
+            <a:r>
+              <a:rPr lang="en-US" sz="800">
+                <a:solidFill>
+                  <a:srgbClr val="000000">
+                    <a:alpha val="50000"/>
+                  </a:srgbClr>
+                </a:solidFill>
+                <a:latin typeface="Aptos" panose="020B0004020202020204" pitchFamily="34" charset="0"/>
+              </a:rPr>
+              <a:t>INTERNAL. This information is accessible to ADB Management and Staff. It may be shared outside ADB with appropriate permission.</a:t>
+            </a:r>
+          </a:p>
+        </p:txBody>
+      </p:sp>
     </p:spTree>
   </p:cSld>
   <p:clrMap bg1="lt1" tx1="dk1" bg2="lt2" tx2="dk2" accent1="accent1" accent2="accent2" accent3="accent3" accent4="accent4" accent5="accent5" accent6="accent6" hlink="hlink" folHlink="folHlink"/>
@@ -2110,6 +2056,7 @@
         <a:solidFill>
           <a:srgbClr val="153E5C"/>
         </a:solidFill>
+        <a:effectLst/>
       </p:bgPr>
     </p:bg>
     <p:spTree>
@@ -2128,144 +2075,6 @@
       </p:grpSpPr>
       <p:sp>
         <p:nvSpPr>
-          <p:cNvPr id="2" name="Shape 0"/>
-          <p:cNvSpPr/>
-          <p:nvPr/>
-        </p:nvSpPr>
-        <p:spPr>
-          <a:xfrm>
-            <a:off x="0" y="3108960"/>
-            <a:ext cx="12188952" cy="3749040"/>
-          </a:xfrm>
-          <a:custGeom>
-            <a:avLst/>
-            <a:gdLst/>
-            <a:ahLst/>
-            <a:cxnLst/>
-            <a:rect l="l" t="t" r="r" b="b"/>
-            <a:pathLst>
-              <a:path w="12188952" h="3749040">
-                <a:moveTo>
-                  <a:pt x="0" y="3749040"/>
-                </a:moveTo>
-                <a:lnTo>
-                  <a:pt x="0" y="2061972"/>
-                </a:lnTo>
-                <a:lnTo>
-                  <a:pt x="1462674" y="2811780"/>
-                </a:lnTo>
-                <a:lnTo>
-                  <a:pt x="2437790" y="1874520"/>
-                </a:lnTo>
-                <a:lnTo>
-                  <a:pt x="3656686" y="2699309"/>
-                </a:lnTo>
-                <a:lnTo>
-                  <a:pt x="5119360" y="1312164"/>
-                </a:lnTo>
-                <a:lnTo>
-                  <a:pt x="6338255" y="2549347"/>
-                </a:lnTo>
-                <a:lnTo>
-                  <a:pt x="7557150" y="1574597"/>
-                </a:lnTo>
-                <a:lnTo>
-                  <a:pt x="8776045" y="2474366"/>
-                </a:lnTo>
-                <a:lnTo>
-                  <a:pt x="9994941" y="1124712"/>
-                </a:lnTo>
-                <a:lnTo>
-                  <a:pt x="10970057" y="2249424"/>
-                </a:lnTo>
-                <a:lnTo>
-                  <a:pt x="12188952" y="1687068"/>
-                </a:lnTo>
-                <a:lnTo>
-                  <a:pt x="12188952" y="3749040"/>
-                </a:lnTo>
-              </a:path>
-            </a:pathLst>
-          </a:custGeom>
-          <a:solidFill>
-            <a:srgbClr val="1F6F8B">
-              <a:alpha val="45000"/>
-            </a:srgbClr>
-          </a:solidFill>
-          <a:ln/>
-        </p:spPr>
-      </p:sp>
-      <p:sp>
-        <p:nvSpPr>
-          <p:cNvPr id="3" name="Shape 1"/>
-          <p:cNvSpPr/>
-          <p:nvPr/>
-        </p:nvSpPr>
-        <p:spPr>
-          <a:xfrm>
-            <a:off x="0" y="4023360"/>
-            <a:ext cx="12188952" cy="2834640"/>
-          </a:xfrm>
-          <a:custGeom>
-            <a:avLst/>
-            <a:gdLst/>
-            <a:ahLst/>
-            <a:cxnLst/>
-            <a:rect l="l" t="t" r="r" b="b"/>
-            <a:pathLst>
-              <a:path w="12188952" h="2834640">
-                <a:moveTo>
-                  <a:pt x="0" y="2834640"/>
-                </a:moveTo>
-                <a:lnTo>
-                  <a:pt x="0" y="1559052"/>
-                </a:lnTo>
-                <a:lnTo>
-                  <a:pt x="1462674" y="2125980"/>
-                </a:lnTo>
-                <a:lnTo>
-                  <a:pt x="2437790" y="1417320"/>
-                </a:lnTo>
-                <a:lnTo>
-                  <a:pt x="3656686" y="2040941"/>
-                </a:lnTo>
-                <a:lnTo>
-                  <a:pt x="5119360" y="992124"/>
-                </a:lnTo>
-                <a:lnTo>
-                  <a:pt x="6338255" y="1927555"/>
-                </a:lnTo>
-                <a:lnTo>
-                  <a:pt x="7557150" y="1190549"/>
-                </a:lnTo>
-                <a:lnTo>
-                  <a:pt x="8776045" y="1870862"/>
-                </a:lnTo>
-                <a:lnTo>
-                  <a:pt x="9994941" y="850392"/>
-                </a:lnTo>
-                <a:lnTo>
-                  <a:pt x="10970057" y="1700784"/>
-                </a:lnTo>
-                <a:lnTo>
-                  <a:pt x="12188952" y="1275588"/>
-                </a:lnTo>
-                <a:lnTo>
-                  <a:pt x="12188952" y="2834640"/>
-                </a:lnTo>
-              </a:path>
-            </a:pathLst>
-          </a:custGeom>
-          <a:solidFill>
-            <a:srgbClr val="0E2A3F">
-              <a:alpha val="75000"/>
-            </a:srgbClr>
-          </a:solidFill>
-          <a:ln/>
-        </p:spPr>
-      </p:sp>
-      <p:sp>
-        <p:nvSpPr>
           <p:cNvPr id="4" name="Text 2"/>
           <p:cNvSpPr/>
           <p:nvPr/>
@@ -2285,7 +2094,7 @@
           <a:bodyPr wrap="square" lIns="0" tIns="0" rIns="0" bIns="0" rtlCol="0" anchor="ctr"/>
           <a:lstStyle/>
           <a:p>
-            <a:pPr indent="0" marL="0">
+            <a:pPr marL="0" indent="0">
               <a:buNone/>
             </a:pPr>
             <a:r>
@@ -2324,7 +2133,7 @@
           <a:bodyPr wrap="square" lIns="0" tIns="0" rIns="0" bIns="0" rtlCol="0" anchor="ctr"/>
           <a:lstStyle/>
           <a:p>
-            <a:pPr indent="0" marL="0">
+            <a:pPr marL="0" indent="0">
               <a:buNone/>
             </a:pPr>
             <a:r>
@@ -2339,134 +2148,6 @@
               <a:t>Himalayan Slope Instability Model</a:t>
             </a:r>
             <a:endParaRPr lang="en-US" sz="2400" dirty="0"/>
-          </a:p>
-        </p:txBody>
-      </p:sp>
-      <p:sp>
-        <p:nvSpPr>
-          <p:cNvPr id="6" name="Text 4"/>
-          <p:cNvSpPr/>
-          <p:nvPr/>
-        </p:nvSpPr>
-        <p:spPr>
-          <a:xfrm>
-            <a:off x="841248" y="2971800"/>
-            <a:ext cx="7863840" cy="731520"/>
-          </a:xfrm>
-          <a:prstGeom prst="rect">
-            <a:avLst/>
-          </a:prstGeom>
-          <a:noFill/>
-          <a:ln/>
-        </p:spPr>
-        <p:txBody>
-          <a:bodyPr wrap="square" lIns="0" tIns="0" rIns="0" bIns="0" rtlCol="0" anchor="ctr"/>
-          <a:lstStyle/>
-          <a:p>
-            <a:pPr indent="0" marL="0">
-              <a:buNone/>
-            </a:pPr>
-            <a:r>
-              <a:rPr lang="en-US" sz="1500" dirty="0">
-                <a:solidFill>
-                  <a:srgbClr val="AECBDD"/>
-                </a:solidFill>
-                <a:latin typeface="Calibri" pitchFamily="34" charset="0"/>
-                <a:ea typeface="Calibri" pitchFamily="34" charset="-122"/>
-                <a:cs typeface="Calibri" pitchFamily="34" charset="-120"/>
-              </a:rPr>
-              <a:t>A landslide exposure screen for every mountain province of the Hindu Kush Himalaya — present day and to 2060.</a:t>
-            </a:r>
-            <a:endParaRPr lang="en-US" sz="1500" dirty="0"/>
-          </a:p>
-        </p:txBody>
-      </p:sp>
-      <p:sp>
-        <p:nvSpPr>
-          <p:cNvPr id="7" name="Shape 5"/>
-          <p:cNvSpPr/>
-          <p:nvPr/>
-        </p:nvSpPr>
-        <p:spPr>
-          <a:xfrm>
-            <a:off x="9966960" y="1463040"/>
-            <a:ext cx="502920" cy="452628"/>
-          </a:xfrm>
-          <a:prstGeom prst="triangle">
-            <a:avLst/>
-          </a:prstGeom>
-          <a:solidFill>
-            <a:srgbClr val="FFFFFF"/>
-          </a:solidFill>
-          <a:ln w="9525">
-            <a:solidFill>
-              <a:srgbClr val="FFFFFF"/>
-            </a:solidFill>
-            <a:prstDash val="solid"/>
-          </a:ln>
-        </p:spPr>
-      </p:sp>
-      <p:sp>
-        <p:nvSpPr>
-          <p:cNvPr id="8" name="Shape 6"/>
-          <p:cNvSpPr/>
-          <p:nvPr/>
-        </p:nvSpPr>
-        <p:spPr>
-          <a:xfrm>
-            <a:off x="10652760" y="1517904"/>
-            <a:ext cx="457200" cy="457200"/>
-          </a:xfrm>
-          <a:prstGeom prst="diamond">
-            <a:avLst/>
-          </a:prstGeom>
-          <a:solidFill>
-            <a:srgbClr val="A50026"/>
-          </a:solidFill>
-          <a:ln w="9525">
-            <a:solidFill>
-              <a:srgbClr val="FFFFFF"/>
-            </a:solidFill>
-            <a:prstDash val="solid"/>
-          </a:ln>
-        </p:spPr>
-      </p:sp>
-      <p:sp>
-        <p:nvSpPr>
-          <p:cNvPr id="9" name="Text 7"/>
-          <p:cNvSpPr/>
-          <p:nvPr/>
-        </p:nvSpPr>
-        <p:spPr>
-          <a:xfrm>
-            <a:off x="8869680" y="2148840"/>
-            <a:ext cx="2926080" cy="365760"/>
-          </a:xfrm>
-          <a:prstGeom prst="rect">
-            <a:avLst/>
-          </a:prstGeom>
-          <a:noFill/>
-          <a:ln/>
-        </p:spPr>
-        <p:txBody>
-          <a:bodyPr wrap="square" rtlCol="0" anchor="ctr"/>
-          <a:lstStyle/>
-          <a:p>
-            <a:pPr algn="ctr" indent="0" marL="0">
-              <a:buNone/>
-            </a:pPr>
-            <a:r>
-              <a:rPr lang="en-US" sz="1100" i="1" dirty="0">
-                <a:solidFill>
-                  <a:srgbClr val="AECBDD"/>
-                </a:solidFill>
-                <a:latin typeface="Calibri" pitchFamily="34" charset="0"/>
-                <a:ea typeface="Calibri" pitchFamily="34" charset="-122"/>
-                <a:cs typeface="Calibri" pitchFamily="34" charset="-120"/>
-              </a:rPr>
-              <a:t>colour is exposure • shape is mechanism</a:t>
-            </a:r>
-            <a:endParaRPr lang="en-US" sz="1100" dirty="0"/>
           </a:p>
         </p:txBody>
       </p:sp>
@@ -2486,6 +2167,7 @@
         <a:solidFill>
           <a:srgbClr val="F4F6F9"/>
         </a:solidFill>
+        <a:effectLst/>
       </p:bgPr>
     </p:bg>
     <p:spTree>
@@ -2523,7 +2205,7 @@
           <a:bodyPr wrap="square" lIns="0" tIns="0" rIns="0" bIns="0" rtlCol="0" anchor="ctr"/>
           <a:lstStyle/>
           <a:p>
-            <a:pPr indent="0" marL="0">
+            <a:pPr marL="0" indent="0">
               <a:buNone/>
             </a:pPr>
             <a:r>
@@ -2567,13 +2249,20 @@
             <a:prstDash val="solid"/>
           </a:ln>
           <a:effectLst>
-            <a:outerShdw sx="100000" sy="100000" kx="0" ky="0" algn="bl" rotWithShape="0" blurRad="1524" dist="508" dir="5400000">
+            <a:outerShdw blurRad="1524" dist="508" dir="5400000" algn="bl" rotWithShape="0">
               <a:srgbClr val="16324A">
                 <a:alpha val="25000"/>
               </a:srgbClr>
             </a:outerShdw>
           </a:effectLst>
         </p:spPr>
+        <p:txBody>
+          <a:bodyPr/>
+          <a:lstStyle/>
+          <a:p>
+            <a:endParaRPr lang="en-US"/>
+          </a:p>
+        </p:txBody>
       </p:sp>
       <p:sp>
         <p:nvSpPr>
@@ -2599,6 +2288,13 @@
             <a:prstDash val="solid"/>
           </a:ln>
         </p:spPr>
+        <p:txBody>
+          <a:bodyPr/>
+          <a:lstStyle/>
+          <a:p>
+            <a:endParaRPr lang="en-US"/>
+          </a:p>
+        </p:txBody>
       </p:sp>
       <p:sp>
         <p:nvSpPr>
@@ -2621,7 +2317,7 @@
           <a:bodyPr wrap="square" lIns="0" tIns="0" rIns="0" bIns="0" rtlCol="0" anchor="ctr"/>
           <a:lstStyle/>
           <a:p>
-            <a:pPr indent="0" marL="0">
+            <a:pPr marL="0" indent="0">
               <a:buNone/>
             </a:pPr>
             <a:r>
@@ -2660,7 +2356,7 @@
           <a:bodyPr wrap="square" lIns="0" tIns="0" rIns="0" bIns="0" rtlCol="0" anchor="ctr"/>
           <a:lstStyle/>
           <a:p>
-            <a:pPr indent="0" marL="0">
+            <a:pPr marL="0" indent="0">
               <a:buNone/>
             </a:pPr>
             <a:r>
@@ -2704,13 +2400,20 @@
             <a:prstDash val="solid"/>
           </a:ln>
           <a:effectLst>
-            <a:outerShdw sx="100000" sy="100000" kx="0" ky="0" algn="bl" rotWithShape="0" blurRad="1524" dist="508" dir="5400000">
+            <a:outerShdw blurRad="1524" dist="508" dir="5400000" algn="bl" rotWithShape="0">
               <a:srgbClr val="16324A">
                 <a:alpha val="25000"/>
               </a:srgbClr>
             </a:outerShdw>
           </a:effectLst>
         </p:spPr>
+        <p:txBody>
+          <a:bodyPr/>
+          <a:lstStyle/>
+          <a:p>
+            <a:endParaRPr lang="en-US"/>
+          </a:p>
+        </p:txBody>
       </p:sp>
       <p:sp>
         <p:nvSpPr>
@@ -2736,6 +2439,13 @@
             <a:prstDash val="solid"/>
           </a:ln>
         </p:spPr>
+        <p:txBody>
+          <a:bodyPr/>
+          <a:lstStyle/>
+          <a:p>
+            <a:endParaRPr lang="en-US"/>
+          </a:p>
+        </p:txBody>
       </p:sp>
       <p:sp>
         <p:nvSpPr>
@@ -2758,7 +2468,7 @@
           <a:bodyPr wrap="square" lIns="0" tIns="0" rIns="0" bIns="0" rtlCol="0" anchor="ctr"/>
           <a:lstStyle/>
           <a:p>
-            <a:pPr indent="0" marL="0">
+            <a:pPr marL="0" indent="0">
               <a:buNone/>
             </a:pPr>
             <a:r>
@@ -2797,7 +2507,7 @@
           <a:bodyPr wrap="square" lIns="0" tIns="0" rIns="0" bIns="0" rtlCol="0" anchor="ctr"/>
           <a:lstStyle/>
           <a:p>
-            <a:pPr indent="0" marL="0">
+            <a:pPr marL="0" indent="0">
               <a:buNone/>
             </a:pPr>
             <a:r>
@@ -2841,13 +2551,20 @@
             <a:prstDash val="solid"/>
           </a:ln>
           <a:effectLst>
-            <a:outerShdw sx="100000" sy="100000" kx="0" ky="0" algn="bl" rotWithShape="0" blurRad="1524" dist="508" dir="5400000">
+            <a:outerShdw blurRad="1524" dist="508" dir="5400000" algn="bl" rotWithShape="0">
               <a:srgbClr val="16324A">
                 <a:alpha val="25000"/>
               </a:srgbClr>
             </a:outerShdw>
           </a:effectLst>
         </p:spPr>
+        <p:txBody>
+          <a:bodyPr/>
+          <a:lstStyle/>
+          <a:p>
+            <a:endParaRPr lang="en-US"/>
+          </a:p>
+        </p:txBody>
       </p:sp>
       <p:sp>
         <p:nvSpPr>
@@ -2873,6 +2590,13 @@
             <a:prstDash val="solid"/>
           </a:ln>
         </p:spPr>
+        <p:txBody>
+          <a:bodyPr/>
+          <a:lstStyle/>
+          <a:p>
+            <a:endParaRPr lang="en-US"/>
+          </a:p>
+        </p:txBody>
       </p:sp>
       <p:sp>
         <p:nvSpPr>
@@ -2895,7 +2619,7 @@
           <a:bodyPr wrap="square" lIns="0" tIns="0" rIns="0" bIns="0" rtlCol="0" anchor="ctr"/>
           <a:lstStyle/>
           <a:p>
-            <a:pPr indent="0" marL="0">
+            <a:pPr marL="0" indent="0">
               <a:buNone/>
             </a:pPr>
             <a:r>
@@ -2934,7 +2658,7 @@
           <a:bodyPr wrap="square" lIns="0" tIns="0" rIns="0" bIns="0" rtlCol="0" anchor="ctr"/>
           <a:lstStyle/>
           <a:p>
-            <a:pPr indent="0" marL="0">
+            <a:pPr marL="0" indent="0">
               <a:buNone/>
             </a:pPr>
             <a:r>
@@ -2978,13 +2702,20 @@
             <a:prstDash val="solid"/>
           </a:ln>
           <a:effectLst>
-            <a:outerShdw sx="100000" sy="100000" kx="0" ky="0" algn="bl" rotWithShape="0" blurRad="1524" dist="508" dir="5400000">
+            <a:outerShdw blurRad="1524" dist="508" dir="5400000" algn="bl" rotWithShape="0">
               <a:srgbClr val="16324A">
                 <a:alpha val="25000"/>
               </a:srgbClr>
             </a:outerShdw>
           </a:effectLst>
         </p:spPr>
+        <p:txBody>
+          <a:bodyPr/>
+          <a:lstStyle/>
+          <a:p>
+            <a:endParaRPr lang="en-US"/>
+          </a:p>
+        </p:txBody>
       </p:sp>
       <p:sp>
         <p:nvSpPr>
@@ -3010,6 +2741,13 @@
             <a:prstDash val="solid"/>
           </a:ln>
         </p:spPr>
+        <p:txBody>
+          <a:bodyPr/>
+          <a:lstStyle/>
+          <a:p>
+            <a:endParaRPr lang="en-US"/>
+          </a:p>
+        </p:txBody>
       </p:sp>
       <p:sp>
         <p:nvSpPr>
@@ -3032,7 +2770,7 @@
           <a:bodyPr wrap="square" lIns="0" tIns="0" rIns="0" bIns="0" rtlCol="0" anchor="ctr"/>
           <a:lstStyle/>
           <a:p>
-            <a:pPr indent="0" marL="0">
+            <a:pPr marL="0" indent="0">
               <a:buNone/>
             </a:pPr>
             <a:r>
@@ -3071,7 +2809,7 @@
           <a:bodyPr wrap="square" lIns="0" tIns="0" rIns="0" bIns="0" rtlCol="0" anchor="ctr"/>
           <a:lstStyle/>
           <a:p>
-            <a:pPr indent="0" marL="0">
+            <a:pPr marL="0" indent="0">
               <a:buNone/>
             </a:pPr>
             <a:r>
@@ -3105,6 +2843,7 @@
         <a:solidFill>
           <a:srgbClr val="FFFFFF"/>
         </a:solidFill>
+        <a:effectLst/>
       </p:bgPr>
     </p:bg>
     <p:spTree>
@@ -3142,7 +2881,7 @@
           <a:bodyPr wrap="square" lIns="0" tIns="0" rIns="0" bIns="0" rtlCol="0" anchor="ctr"/>
           <a:lstStyle/>
           <a:p>
-            <a:pPr indent="0" marL="0">
+            <a:pPr marL="0" indent="0">
               <a:buNone/>
             </a:pPr>
             <a:r>
@@ -3186,13 +2925,20 @@
             <a:prstDash val="solid"/>
           </a:ln>
           <a:effectLst>
-            <a:outerShdw sx="100000" sy="100000" kx="0" ky="0" algn="bl" rotWithShape="0" blurRad="1524" dist="508" dir="5400000">
+            <a:outerShdw blurRad="1524" dist="508" dir="5400000" algn="bl" rotWithShape="0">
               <a:srgbClr val="16324A">
                 <a:alpha val="25000"/>
               </a:srgbClr>
             </a:outerShdw>
           </a:effectLst>
         </p:spPr>
+        <p:txBody>
+          <a:bodyPr/>
+          <a:lstStyle/>
+          <a:p>
+            <a:endParaRPr lang="en-US"/>
+          </a:p>
+        </p:txBody>
       </p:sp>
       <p:sp>
         <p:nvSpPr>
@@ -3215,7 +2961,7 @@
           <a:bodyPr wrap="square" lIns="0" tIns="0" rIns="0" bIns="0" rtlCol="0" anchor="ctr"/>
           <a:lstStyle/>
           <a:p>
-            <a:pPr indent="0" marL="0">
+            <a:pPr marL="0" indent="0">
               <a:lnSpc>
                 <a:spcPts val="2600"/>
               </a:lnSpc>
@@ -3235,7 +2981,7 @@
             <a:endParaRPr lang="en-US" sz="1300" dirty="0"/>
           </a:p>
           <a:p>
-            <a:pPr indent="0" marL="0">
+            <a:pPr marL="0" indent="0">
               <a:lnSpc>
                 <a:spcPts val="2600"/>
               </a:lnSpc>
@@ -3255,7 +3001,7 @@
             <a:endParaRPr lang="en-US" sz="1300" dirty="0"/>
           </a:p>
           <a:p>
-            <a:pPr indent="0" marL="0">
+            <a:pPr marL="0" indent="0">
               <a:lnSpc>
                 <a:spcPts val="2600"/>
               </a:lnSpc>
@@ -3275,7 +3021,7 @@
             <a:endParaRPr lang="en-US" sz="1300" dirty="0"/>
           </a:p>
           <a:p>
-            <a:pPr indent="0" marL="0">
+            <a:pPr marL="0" indent="0">
               <a:lnSpc>
                 <a:spcPts val="2600"/>
               </a:lnSpc>
@@ -3295,7 +3041,7 @@
             <a:endParaRPr lang="en-US" sz="1300" dirty="0"/>
           </a:p>
           <a:p>
-            <a:pPr indent="0" marL="0">
+            <a:pPr marL="0" indent="0">
               <a:lnSpc>
                 <a:spcPts val="2600"/>
               </a:lnSpc>
@@ -3315,7 +3061,7 @@
             <a:endParaRPr lang="en-US" sz="1300" dirty="0"/>
           </a:p>
           <a:p>
-            <a:pPr indent="0" marL="0">
+            <a:pPr marL="0" indent="0">
               <a:lnSpc>
                 <a:spcPts val="2600"/>
               </a:lnSpc>
@@ -3362,13 +3108,20 @@
             <a:prstDash val="solid"/>
           </a:ln>
           <a:effectLst>
-            <a:outerShdw sx="100000" sy="100000" kx="0" ky="0" algn="bl" rotWithShape="0" blurRad="1524" dist="508" dir="5400000">
+            <a:outerShdw blurRad="1524" dist="508" dir="5400000" algn="bl" rotWithShape="0">
               <a:srgbClr val="16324A">
                 <a:alpha val="25000"/>
               </a:srgbClr>
             </a:outerShdw>
           </a:effectLst>
         </p:spPr>
+        <p:txBody>
+          <a:bodyPr/>
+          <a:lstStyle/>
+          <a:p>
+            <a:endParaRPr lang="en-US"/>
+          </a:p>
+        </p:txBody>
       </p:sp>
       <p:sp>
         <p:nvSpPr>
@@ -3391,7 +3144,7 @@
           <a:bodyPr wrap="square" lIns="0" tIns="0" rIns="0" bIns="0" rtlCol="0" anchor="ctr"/>
           <a:lstStyle/>
           <a:p>
-            <a:pPr indent="0" marL="0">
+            <a:pPr marL="0" indent="0">
               <a:buNone/>
             </a:pPr>
             <a:r>
@@ -3425,6 +3178,7 @@
         <a:solidFill>
           <a:srgbClr val="153E5C"/>
         </a:solidFill>
+        <a:effectLst/>
       </p:bgPr>
     </p:bg>
     <p:spTree>
@@ -3509,6 +3263,13 @@
           </a:solidFill>
           <a:ln/>
         </p:spPr>
+        <p:txBody>
+          <a:bodyPr/>
+          <a:lstStyle/>
+          <a:p>
+            <a:endParaRPr lang="en-US"/>
+          </a:p>
+        </p:txBody>
       </p:sp>
       <p:sp>
         <p:nvSpPr>
@@ -3578,6 +3339,13 @@
           </a:solidFill>
           <a:ln/>
         </p:spPr>
+        <p:txBody>
+          <a:bodyPr/>
+          <a:lstStyle/>
+          <a:p>
+            <a:endParaRPr lang="en-US"/>
+          </a:p>
+        </p:txBody>
       </p:sp>
       <p:sp>
         <p:nvSpPr>
@@ -3600,7 +3368,7 @@
           <a:bodyPr wrap="square" lIns="0" tIns="0" rIns="0" bIns="0" rtlCol="0" anchor="ctr"/>
           <a:lstStyle/>
           <a:p>
-            <a:pPr indent="0" marL="0">
+            <a:pPr marL="0" indent="0">
               <a:buNone/>
             </a:pPr>
             <a:r>
@@ -3724,7 +3492,7 @@
           <a:bodyPr wrap="square" lIns="0" tIns="0" rIns="0" bIns="0" rtlCol="0" anchor="ctr"/>
           <a:lstStyle/>
           <a:p>
-            <a:pPr indent="0" marL="0">
+            <a:pPr marL="0" indent="0">
               <a:buNone/>
             </a:pPr>
             <a:r>
@@ -3758,6 +3526,7 @@
         <a:solidFill>
           <a:srgbClr val="F4F6F9"/>
         </a:solidFill>
+        <a:effectLst/>
       </p:bgPr>
     </p:bg>
     <p:spTree>
@@ -3795,7 +3564,7 @@
           <a:bodyPr wrap="square" lIns="0" tIns="0" rIns="0" bIns="0" rtlCol="0" anchor="ctr"/>
           <a:lstStyle/>
           <a:p>
-            <a:pPr indent="0" marL="0">
+            <a:pPr marL="0" indent="0">
               <a:buNone/>
             </a:pPr>
             <a:r>
@@ -3804,10 +3573,8 @@
                   <a:srgbClr val="153E5C"/>
                 </a:solidFill>
                 <a:latin typeface="Cambria" pitchFamily="34" charset="0"/>
-                <a:ea typeface="Cambria" pitchFamily="34" charset="-122"/>
-                <a:cs typeface="Cambria" pitchFamily="34" charset="-120"/>
-              </a:rPr>
-              <a:t>One model, one product, one page</a:t>
+              </a:rPr>
+              <a:t>H-SIM Regional Coverage</a:t>
             </a:r>
             <a:endParaRPr lang="en-US" sz="3000" dirty="0"/>
           </a:p>
@@ -3834,7 +3601,7 @@
           <a:bodyPr wrap="square" lIns="0" tIns="0" rIns="0" bIns="0" rtlCol="0" anchor="ctr"/>
           <a:lstStyle/>
           <a:p>
-            <a:pPr indent="0" marL="0">
+            <a:pPr marL="0" indent="0">
               <a:buNone/>
             </a:pPr>
             <a:r>
@@ -3878,13 +3645,20 @@
             <a:prstDash val="solid"/>
           </a:ln>
           <a:effectLst>
-            <a:outerShdw sx="100000" sy="100000" kx="0" ky="0" algn="bl" rotWithShape="0" blurRad="1524" dist="508" dir="5400000">
+            <a:outerShdw blurRad="1524" dist="508" dir="5400000" algn="bl" rotWithShape="0">
               <a:srgbClr val="16324A">
                 <a:alpha val="25000"/>
               </a:srgbClr>
             </a:outerShdw>
           </a:effectLst>
         </p:spPr>
+        <p:txBody>
+          <a:bodyPr/>
+          <a:lstStyle/>
+          <a:p>
+            <a:endParaRPr lang="en-US"/>
+          </a:p>
+        </p:txBody>
       </p:sp>
       <p:sp>
         <p:nvSpPr>
@@ -3907,7 +3681,7 @@
           <a:bodyPr wrap="square" rtlCol="0" anchor="ctr"/>
           <a:lstStyle/>
           <a:p>
-            <a:pPr algn="ctr" indent="0" marL="0">
+            <a:pPr marL="0" indent="0" algn="ctr">
               <a:buNone/>
             </a:pPr>
             <a:r>
@@ -3946,7 +3720,7 @@
           <a:bodyPr wrap="square" rtlCol="0" anchor="ctr"/>
           <a:lstStyle/>
           <a:p>
-            <a:pPr algn="ctr" indent="0" marL="0">
+            <a:pPr marL="0" indent="0" algn="ctr">
               <a:buNone/>
             </a:pPr>
             <a:r>
@@ -3990,13 +3764,20 @@
             <a:prstDash val="solid"/>
           </a:ln>
           <a:effectLst>
-            <a:outerShdw sx="100000" sy="100000" kx="0" ky="0" algn="bl" rotWithShape="0" blurRad="1524" dist="508" dir="5400000">
+            <a:outerShdw blurRad="1524" dist="508" dir="5400000" algn="bl" rotWithShape="0">
               <a:srgbClr val="16324A">
                 <a:alpha val="25000"/>
               </a:srgbClr>
             </a:outerShdw>
           </a:effectLst>
         </p:spPr>
+        <p:txBody>
+          <a:bodyPr/>
+          <a:lstStyle/>
+          <a:p>
+            <a:endParaRPr lang="en-US"/>
+          </a:p>
+        </p:txBody>
       </p:sp>
       <p:sp>
         <p:nvSpPr>
@@ -4019,7 +3800,7 @@
           <a:bodyPr wrap="square" rtlCol="0" anchor="ctr"/>
           <a:lstStyle/>
           <a:p>
-            <a:pPr algn="ctr" indent="0" marL="0">
+            <a:pPr marL="0" indent="0" algn="ctr">
               <a:buNone/>
             </a:pPr>
             <a:r>
@@ -4058,7 +3839,7 @@
           <a:bodyPr wrap="square" rtlCol="0" anchor="ctr"/>
           <a:lstStyle/>
           <a:p>
-            <a:pPr algn="ctr" indent="0" marL="0">
+            <a:pPr marL="0" indent="0" algn="ctr">
               <a:buNone/>
             </a:pPr>
             <a:r>
@@ -4102,13 +3883,20 @@
             <a:prstDash val="solid"/>
           </a:ln>
           <a:effectLst>
-            <a:outerShdw sx="100000" sy="100000" kx="0" ky="0" algn="bl" rotWithShape="0" blurRad="1524" dist="508" dir="5400000">
+            <a:outerShdw blurRad="1524" dist="508" dir="5400000" algn="bl" rotWithShape="0">
               <a:srgbClr val="16324A">
                 <a:alpha val="25000"/>
               </a:srgbClr>
             </a:outerShdw>
           </a:effectLst>
         </p:spPr>
+        <p:txBody>
+          <a:bodyPr/>
+          <a:lstStyle/>
+          <a:p>
+            <a:endParaRPr lang="en-US"/>
+          </a:p>
+        </p:txBody>
       </p:sp>
       <p:sp>
         <p:nvSpPr>
@@ -4131,7 +3919,7 @@
           <a:bodyPr wrap="square" rtlCol="0" anchor="ctr"/>
           <a:lstStyle/>
           <a:p>
-            <a:pPr algn="ctr" indent="0" marL="0">
+            <a:pPr marL="0" indent="0" algn="ctr">
               <a:buNone/>
             </a:pPr>
             <a:r>
@@ -4170,7 +3958,7 @@
           <a:bodyPr wrap="square" rtlCol="0" anchor="ctr"/>
           <a:lstStyle/>
           <a:p>
-            <a:pPr algn="ctr" indent="0" marL="0">
+            <a:pPr marL="0" indent="0" algn="ctr">
               <a:buNone/>
             </a:pPr>
             <a:r>
@@ -4214,13 +4002,20 @@
             <a:prstDash val="solid"/>
           </a:ln>
           <a:effectLst>
-            <a:outerShdw sx="100000" sy="100000" kx="0" ky="0" algn="bl" rotWithShape="0" blurRad="1524" dist="508" dir="5400000">
+            <a:outerShdw blurRad="1524" dist="508" dir="5400000" algn="bl" rotWithShape="0">
               <a:srgbClr val="16324A">
                 <a:alpha val="25000"/>
               </a:srgbClr>
             </a:outerShdw>
           </a:effectLst>
         </p:spPr>
+        <p:txBody>
+          <a:bodyPr/>
+          <a:lstStyle/>
+          <a:p>
+            <a:endParaRPr lang="en-US" dirty="0"/>
+          </a:p>
+        </p:txBody>
       </p:sp>
       <p:sp>
         <p:nvSpPr>
@@ -4243,7 +4038,7 @@
           <a:bodyPr wrap="square" rtlCol="0" anchor="ctr"/>
           <a:lstStyle/>
           <a:p>
-            <a:pPr algn="ctr" indent="0" marL="0">
+            <a:pPr marL="0" indent="0" algn="ctr">
               <a:buNone/>
             </a:pPr>
             <a:r>
@@ -4282,7 +4077,7 @@
           <a:bodyPr wrap="square" rtlCol="0" anchor="ctr"/>
           <a:lstStyle/>
           <a:p>
-            <a:pPr algn="ctr" indent="0" marL="0">
+            <a:pPr marL="0" indent="0" algn="ctr">
               <a:buNone/>
             </a:pPr>
             <a:r>
@@ -4297,164 +4092,6 @@
               <a:t>planning horizon under CMIP6</a:t>
             </a:r>
             <a:endParaRPr lang="en-US" sz="1250" dirty="0"/>
-          </a:p>
-        </p:txBody>
-      </p:sp>
-      <p:sp>
-        <p:nvSpPr>
-          <p:cNvPr id="16" name="Shape 14"/>
-          <p:cNvSpPr/>
-          <p:nvPr/>
-        </p:nvSpPr>
-        <p:spPr>
-          <a:xfrm>
-            <a:off x="566928" y="4069080"/>
-            <a:ext cx="11055096" cy="2148840"/>
-          </a:xfrm>
-          <a:prstGeom prst="roundRect">
-            <a:avLst>
-              <a:gd name="adj" fmla="val 3830"/>
-            </a:avLst>
-          </a:prstGeom>
-          <a:solidFill>
-            <a:srgbClr val="FFFFFF"/>
-          </a:solidFill>
-          <a:ln w="9525">
-            <a:solidFill>
-              <a:srgbClr val="E4E8EE"/>
-            </a:solidFill>
-            <a:prstDash val="solid"/>
-          </a:ln>
-          <a:effectLst>
-            <a:outerShdw sx="100000" sy="100000" kx="0" ky="0" algn="bl" rotWithShape="0" blurRad="1524" dist="508" dir="5400000">
-              <a:srgbClr val="16324A">
-                <a:alpha val="25000"/>
-              </a:srgbClr>
-            </a:outerShdw>
-          </a:effectLst>
-        </p:spPr>
-      </p:sp>
-      <p:sp>
-        <p:nvSpPr>
-          <p:cNvPr id="17" name="Text 15"/>
-          <p:cNvSpPr/>
-          <p:nvPr/>
-        </p:nvSpPr>
-        <p:spPr>
-          <a:xfrm>
-            <a:off x="777240" y="4224528"/>
-            <a:ext cx="5486400" cy="365760"/>
-          </a:xfrm>
-          <a:prstGeom prst="rect">
-            <a:avLst/>
-          </a:prstGeom>
-          <a:noFill/>
-          <a:ln/>
-        </p:spPr>
-        <p:txBody>
-          <a:bodyPr wrap="square" lIns="0" tIns="0" rIns="0" bIns="0" rtlCol="0" anchor="ctr"/>
-          <a:lstStyle/>
-          <a:p>
-            <a:pPr indent="0" marL="0">
-              <a:buNone/>
-            </a:pPr>
-            <a:r>
-              <a:rPr lang="en-US" sz="1500" b="1" dirty="0">
-                <a:solidFill>
-                  <a:srgbClr val="153E5C"/>
-                </a:solidFill>
-                <a:latin typeface="Cambria" pitchFamily="34" charset="0"/>
-                <a:ea typeface="Cambria" pitchFamily="34" charset="-122"/>
-                <a:cs typeface="Cambria" pitchFamily="34" charset="-120"/>
-              </a:rPr>
-              <a:t>What a meeting sees</a:t>
-            </a:r>
-            <a:endParaRPr lang="en-US" sz="1500" dirty="0"/>
-          </a:p>
-        </p:txBody>
-      </p:sp>
-      <p:sp>
-        <p:nvSpPr>
-          <p:cNvPr id="18" name="Text 16"/>
-          <p:cNvSpPr/>
-          <p:nvPr/>
-        </p:nvSpPr>
-        <p:spPr>
-          <a:xfrm>
-            <a:off x="777240" y="4617720"/>
-            <a:ext cx="10607040" cy="1463040"/>
-          </a:xfrm>
-          <a:prstGeom prst="rect">
-            <a:avLst/>
-          </a:prstGeom>
-          <a:noFill/>
-          <a:ln/>
-        </p:spPr>
-        <p:txBody>
-          <a:bodyPr wrap="square" lIns="0" tIns="0" rIns="0" bIns="0" rtlCol="0" anchor="ctr"/>
-          <a:lstStyle/>
-          <a:p>
-            <a:pPr marL="342900" indent="-342900">
-              <a:spcAft>
-                <a:spcPts val="800"/>
-              </a:spcAft>
-              <a:buSzPct val="100000"/>
-              <a:buChar char="•"/>
-            </a:pPr>
-            <a:r>
-              <a:rPr lang="en-US" sz="1400" dirty="0">
-                <a:solidFill>
-                  <a:srgbClr val="101418"/>
-                </a:solidFill>
-                <a:latin typeface="Calibri" pitchFamily="34" charset="0"/>
-                <a:ea typeface="Calibri" pitchFamily="34" charset="-122"/>
-                <a:cs typeface="Calibri" pitchFamily="34" charset="-120"/>
-              </a:rPr>
-              <a:t>Pick a country, pick a province — its interactive hazard map loads in place.</a:t>
-            </a:r>
-            <a:endParaRPr lang="en-US" sz="1400" dirty="0"/>
-          </a:p>
-          <a:p>
-            <a:pPr marL="342900" indent="-342900">
-              <a:spcAft>
-                <a:spcPts val="800"/>
-              </a:spcAft>
-              <a:buSzPct val="100000"/>
-              <a:buChar char="•"/>
-            </a:pPr>
-            <a:r>
-              <a:rPr lang="en-US" sz="1400" dirty="0">
-                <a:solidFill>
-                  <a:srgbClr val="101418"/>
-                </a:solidFill>
-                <a:latin typeface="Calibri" pitchFamily="34" charset="0"/>
-                <a:ea typeface="Calibri" pitchFamily="34" charset="-122"/>
-                <a:cs typeface="Calibri" pitchFamily="34" charset="-120"/>
-              </a:rPr>
-              <a:t>A ranked table of all 95 provinces: unstable area, settlements and road-km exposed. Rows click into the map.</a:t>
-            </a:r>
-            <a:endParaRPr lang="en-US" sz="1400" dirty="0"/>
-          </a:p>
-          <a:p>
-            <a:pPr marL="342900" indent="-342900">
-              <a:spcAft>
-                <a:spcPts val="800"/>
-              </a:spcAft>
-              <a:buSzPct val="100000"/>
-              <a:buChar char="•"/>
-            </a:pPr>
-            <a:r>
-              <a:rPr lang="en-US" sz="1400" dirty="0">
-                <a:solidFill>
-                  <a:srgbClr val="101418"/>
-                </a:solidFill>
-                <a:latin typeface="Calibri" pitchFamily="34" charset="0"/>
-                <a:ea typeface="Calibri" pitchFamily="34" charset="-122"/>
-                <a:cs typeface="Calibri" pitchFamily="34" charset="-120"/>
-              </a:rPr>
-              <a:t>Every number is relative and labelled as screening — the app says so on the page.</a:t>
-            </a:r>
-            <a:endParaRPr lang="en-US" sz="1400" dirty="0"/>
           </a:p>
         </p:txBody>
       </p:sp>
@@ -4474,6 +4111,7 @@
         <a:solidFill>
           <a:srgbClr val="FFFFFF"/>
         </a:solidFill>
+        <a:effectLst/>
       </p:bgPr>
     </p:bg>
     <p:spTree>
@@ -4511,7 +4149,7 @@
           <a:bodyPr wrap="square" lIns="0" tIns="0" rIns="0" bIns="0" rtlCol="0" anchor="ctr"/>
           <a:lstStyle/>
           <a:p>
-            <a:pPr indent="0" marL="0">
+            <a:pPr marL="0" indent="0">
               <a:buNone/>
             </a:pPr>
             <a:r>
@@ -4555,13 +4193,20 @@
             <a:prstDash val="solid"/>
           </a:ln>
           <a:effectLst>
-            <a:outerShdw sx="100000" sy="100000" kx="0" ky="0" algn="bl" rotWithShape="0" blurRad="1524" dist="508" dir="5400000">
+            <a:outerShdw blurRad="1524" dist="508" dir="5400000" algn="bl" rotWithShape="0">
               <a:srgbClr val="16324A">
                 <a:alpha val="25000"/>
               </a:srgbClr>
             </a:outerShdw>
           </a:effectLst>
         </p:spPr>
+        <p:txBody>
+          <a:bodyPr/>
+          <a:lstStyle/>
+          <a:p>
+            <a:endParaRPr lang="en-US"/>
+          </a:p>
+        </p:txBody>
       </p:sp>
       <p:sp>
         <p:nvSpPr>
@@ -4587,6 +4232,13 @@
             <a:prstDash val="solid"/>
           </a:ln>
         </p:spPr>
+        <p:txBody>
+          <a:bodyPr/>
+          <a:lstStyle/>
+          <a:p>
+            <a:endParaRPr lang="en-US"/>
+          </a:p>
+        </p:txBody>
       </p:sp>
       <p:sp>
         <p:nvSpPr>
@@ -4610,6 +4262,13 @@
             <a:prstDash val="dash"/>
           </a:ln>
         </p:spPr>
+        <p:txBody>
+          <a:bodyPr/>
+          <a:lstStyle/>
+          <a:p>
+            <a:endParaRPr lang="en-US"/>
+          </a:p>
+        </p:txBody>
       </p:sp>
       <p:sp>
         <p:nvSpPr>
@@ -4632,7 +4291,7 @@
           <a:bodyPr wrap="square" lIns="0" tIns="0" rIns="0" bIns="0" rtlCol="0" anchor="ctr"/>
           <a:lstStyle/>
           <a:p>
-            <a:pPr indent="0" marL="0">
+            <a:pPr marL="0" indent="0">
               <a:buNone/>
             </a:pPr>
             <a:r>
@@ -4671,7 +4330,7 @@
           <a:bodyPr wrap="square" lIns="0" tIns="0" rIns="0" bIns="0" rtlCol="0" anchor="ctr"/>
           <a:lstStyle/>
           <a:p>
-            <a:pPr indent="0" marL="0">
+            <a:pPr marL="0" indent="0">
               <a:buNone/>
             </a:pPr>
             <a:r>
@@ -4710,7 +4369,7 @@
           <a:bodyPr wrap="square" lIns="0" tIns="0" rIns="0" bIns="0" rtlCol="0" anchor="ctr"/>
           <a:lstStyle/>
           <a:p>
-            <a:pPr indent="0" marL="0">
+            <a:pPr marL="0" indent="0">
               <a:buNone/>
             </a:pPr>
             <a:r>
@@ -4749,7 +4408,7 @@
           <a:bodyPr wrap="square" lIns="0" tIns="0" rIns="0" bIns="0" rtlCol="0" anchor="ctr"/>
           <a:lstStyle/>
           <a:p>
-            <a:pPr indent="0" marL="0">
+            <a:pPr marL="0" indent="0">
               <a:buNone/>
             </a:pPr>
             <a:r>
@@ -4788,7 +4447,7 @@
           <a:bodyPr wrap="square" lIns="0" tIns="0" rIns="0" bIns="0" rtlCol="0" anchor="ctr"/>
           <a:lstStyle/>
           <a:p>
-            <a:pPr indent="0" marL="0">
+            <a:pPr marL="0" indent="0">
               <a:buNone/>
             </a:pPr>
             <a:r>
@@ -4832,13 +4491,20 @@
             <a:prstDash val="solid"/>
           </a:ln>
           <a:effectLst>
-            <a:outerShdw sx="100000" sy="100000" kx="0" ky="0" algn="bl" rotWithShape="0" blurRad="1524" dist="508" dir="5400000">
+            <a:outerShdw blurRad="1524" dist="508" dir="5400000" algn="bl" rotWithShape="0">
               <a:srgbClr val="16324A">
                 <a:alpha val="25000"/>
               </a:srgbClr>
             </a:outerShdw>
           </a:effectLst>
         </p:spPr>
+        <p:txBody>
+          <a:bodyPr/>
+          <a:lstStyle/>
+          <a:p>
+            <a:endParaRPr lang="en-US"/>
+          </a:p>
+        </p:txBody>
       </p:sp>
       <p:sp>
         <p:nvSpPr>
@@ -4859,6 +4525,13 @@
           </a:solidFill>
           <a:ln/>
         </p:spPr>
+        <p:txBody>
+          <a:bodyPr/>
+          <a:lstStyle/>
+          <a:p>
+            <a:endParaRPr lang="en-US"/>
+          </a:p>
+        </p:txBody>
       </p:sp>
       <p:sp>
         <p:nvSpPr>
@@ -4881,7 +4554,7 @@
           <a:bodyPr wrap="square" lIns="0" tIns="0" rIns="0" bIns="0" rtlCol="0" anchor="ctr"/>
           <a:lstStyle/>
           <a:p>
-            <a:pPr algn="ctr" indent="0" marL="0">
+            <a:pPr marL="0" indent="0" algn="ctr">
               <a:buNone/>
             </a:pPr>
             <a:r>
@@ -4920,7 +4593,7 @@
           <a:bodyPr wrap="square" lIns="0" tIns="0" rIns="0" bIns="0" rtlCol="0" anchor="ctr"/>
           <a:lstStyle/>
           <a:p>
-            <a:pPr indent="0" marL="0">
+            <a:pPr marL="0" indent="0">
               <a:buNone/>
             </a:pPr>
             <a:r>
@@ -4959,7 +4632,7 @@
           <a:bodyPr wrap="square" lIns="0" tIns="0" rIns="0" bIns="0" rtlCol="0" anchor="ctr"/>
           <a:lstStyle/>
           <a:p>
-            <a:pPr indent="0" marL="0">
+            <a:pPr marL="0" indent="0">
               <a:buNone/>
             </a:pPr>
             <a:r>
@@ -5003,13 +4676,20 @@
             <a:prstDash val="solid"/>
           </a:ln>
           <a:effectLst>
-            <a:outerShdw sx="100000" sy="100000" kx="0" ky="0" algn="bl" rotWithShape="0" blurRad="1524" dist="508" dir="5400000">
+            <a:outerShdw blurRad="1524" dist="508" dir="5400000" algn="bl" rotWithShape="0">
               <a:srgbClr val="16324A">
                 <a:alpha val="25000"/>
               </a:srgbClr>
             </a:outerShdw>
           </a:effectLst>
         </p:spPr>
+        <p:txBody>
+          <a:bodyPr/>
+          <a:lstStyle/>
+          <a:p>
+            <a:endParaRPr lang="en-US"/>
+          </a:p>
+        </p:txBody>
       </p:sp>
       <p:sp>
         <p:nvSpPr>
@@ -5030,6 +4710,13 @@
           </a:solidFill>
           <a:ln/>
         </p:spPr>
+        <p:txBody>
+          <a:bodyPr/>
+          <a:lstStyle/>
+          <a:p>
+            <a:endParaRPr lang="en-US"/>
+          </a:p>
+        </p:txBody>
       </p:sp>
       <p:sp>
         <p:nvSpPr>
@@ -5052,7 +4739,7 @@
           <a:bodyPr wrap="square" lIns="0" tIns="0" rIns="0" bIns="0" rtlCol="0" anchor="ctr"/>
           <a:lstStyle/>
           <a:p>
-            <a:pPr algn="ctr" indent="0" marL="0">
+            <a:pPr marL="0" indent="0" algn="ctr">
               <a:buNone/>
             </a:pPr>
             <a:r>
@@ -5091,7 +4778,7 @@
           <a:bodyPr wrap="square" lIns="0" tIns="0" rIns="0" bIns="0" rtlCol="0" anchor="ctr"/>
           <a:lstStyle/>
           <a:p>
-            <a:pPr indent="0" marL="0">
+            <a:pPr marL="0" indent="0">
               <a:buNone/>
             </a:pPr>
             <a:r>
@@ -5130,7 +4817,7 @@
           <a:bodyPr wrap="square" lIns="0" tIns="0" rIns="0" bIns="0" rtlCol="0" anchor="ctr"/>
           <a:lstStyle/>
           <a:p>
-            <a:pPr indent="0" marL="0">
+            <a:pPr marL="0" indent="0">
               <a:buNone/>
             </a:pPr>
             <a:r>
@@ -5174,13 +4861,20 @@
             <a:prstDash val="solid"/>
           </a:ln>
           <a:effectLst>
-            <a:outerShdw sx="100000" sy="100000" kx="0" ky="0" algn="bl" rotWithShape="0" blurRad="1524" dist="508" dir="5400000">
+            <a:outerShdw blurRad="1524" dist="508" dir="5400000" algn="bl" rotWithShape="0">
               <a:srgbClr val="16324A">
                 <a:alpha val="25000"/>
               </a:srgbClr>
             </a:outerShdw>
           </a:effectLst>
         </p:spPr>
+        <p:txBody>
+          <a:bodyPr/>
+          <a:lstStyle/>
+          <a:p>
+            <a:endParaRPr lang="en-US"/>
+          </a:p>
+        </p:txBody>
       </p:sp>
       <p:sp>
         <p:nvSpPr>
@@ -5201,6 +4895,13 @@
           </a:solidFill>
           <a:ln/>
         </p:spPr>
+        <p:txBody>
+          <a:bodyPr/>
+          <a:lstStyle/>
+          <a:p>
+            <a:endParaRPr lang="en-US"/>
+          </a:p>
+        </p:txBody>
       </p:sp>
       <p:sp>
         <p:nvSpPr>
@@ -5223,7 +4924,7 @@
           <a:bodyPr wrap="square" lIns="0" tIns="0" rIns="0" bIns="0" rtlCol="0" anchor="ctr"/>
           <a:lstStyle/>
           <a:p>
-            <a:pPr algn="ctr" indent="0" marL="0">
+            <a:pPr marL="0" indent="0" algn="ctr">
               <a:buNone/>
             </a:pPr>
             <a:r>
@@ -5262,7 +4963,7 @@
           <a:bodyPr wrap="square" lIns="0" tIns="0" rIns="0" bIns="0" rtlCol="0" anchor="ctr"/>
           <a:lstStyle/>
           <a:p>
-            <a:pPr indent="0" marL="0">
+            <a:pPr marL="0" indent="0">
               <a:buNone/>
             </a:pPr>
             <a:r>
@@ -5301,7 +5002,7 @@
           <a:bodyPr wrap="square" lIns="0" tIns="0" rIns="0" bIns="0" rtlCol="0" anchor="ctr"/>
           <a:lstStyle/>
           <a:p>
-            <a:pPr indent="0" marL="0">
+            <a:pPr marL="0" indent="0">
               <a:buNone/>
             </a:pPr>
             <a:r>
@@ -5335,6 +5036,7 @@
         <a:solidFill>
           <a:srgbClr val="F4F6F9"/>
         </a:solidFill>
+        <a:effectLst/>
       </p:bgPr>
     </p:bg>
     <p:spTree>
@@ -5372,7 +5074,7 @@
           <a:bodyPr wrap="square" lIns="0" tIns="0" rIns="0" bIns="0" rtlCol="0" anchor="ctr"/>
           <a:lstStyle/>
           <a:p>
-            <a:pPr indent="0" marL="0">
+            <a:pPr marL="0" indent="0">
               <a:buNone/>
             </a:pPr>
             <a:r>
@@ -5416,13 +5118,20 @@
             <a:prstDash val="solid"/>
           </a:ln>
           <a:effectLst>
-            <a:outerShdw sx="100000" sy="100000" kx="0" ky="0" algn="bl" rotWithShape="0" blurRad="1524" dist="508" dir="5400000">
+            <a:outerShdw blurRad="1524" dist="508" dir="5400000" algn="bl" rotWithShape="0">
               <a:srgbClr val="16324A">
                 <a:alpha val="25000"/>
               </a:srgbClr>
             </a:outerShdw>
           </a:effectLst>
         </p:spPr>
+        <p:txBody>
+          <a:bodyPr/>
+          <a:lstStyle/>
+          <a:p>
+            <a:endParaRPr lang="en-US"/>
+          </a:p>
+        </p:txBody>
       </p:sp>
       <p:sp>
         <p:nvSpPr>
@@ -5445,7 +5154,7 @@
           <a:bodyPr wrap="square" rtlCol="0" anchor="ctr"/>
           <a:lstStyle/>
           <a:p>
-            <a:pPr algn="ctr" indent="0" marL="0">
+            <a:pPr marL="0" indent="0" algn="ctr">
               <a:buNone/>
             </a:pPr>
             <a:r>
@@ -5484,7 +5193,7 @@
           <a:bodyPr wrap="square" rtlCol="0" anchor="ctr"/>
           <a:lstStyle/>
           <a:p>
-            <a:pPr algn="ctr" indent="0" marL="0">
+            <a:pPr marL="0" indent="0" algn="ctr">
               <a:buNone/>
             </a:pPr>
             <a:r>
@@ -5501,7 +5210,7 @@
             <a:endParaRPr lang="en-US" sz="1000" dirty="0"/>
           </a:p>
           <a:p>
-            <a:pPr algn="ctr" indent="0" marL="0">
+            <a:pPr marL="0" indent="0" algn="ctr">
               <a:buNone/>
             </a:pPr>
             <a:r>
@@ -5538,6 +5247,13 @@
           </a:solidFill>
           <a:ln/>
         </p:spPr>
+        <p:txBody>
+          <a:bodyPr/>
+          <a:lstStyle/>
+          <a:p>
+            <a:endParaRPr lang="en-US"/>
+          </a:p>
+        </p:txBody>
       </p:sp>
       <p:sp>
         <p:nvSpPr>
@@ -5565,13 +5281,20 @@
             <a:prstDash val="solid"/>
           </a:ln>
           <a:effectLst>
-            <a:outerShdw sx="100000" sy="100000" kx="0" ky="0" algn="bl" rotWithShape="0" blurRad="1524" dist="508" dir="5400000">
+            <a:outerShdw blurRad="1524" dist="508" dir="5400000" algn="bl" rotWithShape="0">
               <a:srgbClr val="16324A">
                 <a:alpha val="25000"/>
               </a:srgbClr>
             </a:outerShdw>
           </a:effectLst>
         </p:spPr>
+        <p:txBody>
+          <a:bodyPr/>
+          <a:lstStyle/>
+          <a:p>
+            <a:endParaRPr lang="en-US"/>
+          </a:p>
+        </p:txBody>
       </p:sp>
       <p:sp>
         <p:nvSpPr>
@@ -5594,7 +5317,7 @@
           <a:bodyPr wrap="square" rtlCol="0" anchor="ctr"/>
           <a:lstStyle/>
           <a:p>
-            <a:pPr algn="ctr" indent="0" marL="0">
+            <a:pPr marL="0" indent="0" algn="ctr">
               <a:buNone/>
             </a:pPr>
             <a:r>
@@ -5633,7 +5356,7 @@
           <a:bodyPr wrap="square" rtlCol="0" anchor="ctr"/>
           <a:lstStyle/>
           <a:p>
-            <a:pPr algn="ctr" indent="0" marL="0">
+            <a:pPr marL="0" indent="0" algn="ctr">
               <a:buNone/>
             </a:pPr>
             <a:r>
@@ -5650,7 +5373,7 @@
             <a:endParaRPr lang="en-US" sz="1000" dirty="0"/>
           </a:p>
           <a:p>
-            <a:pPr algn="ctr" indent="0" marL="0">
+            <a:pPr marL="0" indent="0" algn="ctr">
               <a:buNone/>
             </a:pPr>
             <a:r>
@@ -5687,6 +5410,13 @@
           </a:solidFill>
           <a:ln/>
         </p:spPr>
+        <p:txBody>
+          <a:bodyPr/>
+          <a:lstStyle/>
+          <a:p>
+            <a:endParaRPr lang="en-US"/>
+          </a:p>
+        </p:txBody>
       </p:sp>
       <p:sp>
         <p:nvSpPr>
@@ -5714,13 +5444,20 @@
             <a:prstDash val="solid"/>
           </a:ln>
           <a:effectLst>
-            <a:outerShdw sx="100000" sy="100000" kx="0" ky="0" algn="bl" rotWithShape="0" blurRad="1524" dist="508" dir="5400000">
+            <a:outerShdw blurRad="1524" dist="508" dir="5400000" algn="bl" rotWithShape="0">
               <a:srgbClr val="16324A">
                 <a:alpha val="25000"/>
               </a:srgbClr>
             </a:outerShdw>
           </a:effectLst>
         </p:spPr>
+        <p:txBody>
+          <a:bodyPr/>
+          <a:lstStyle/>
+          <a:p>
+            <a:endParaRPr lang="en-US"/>
+          </a:p>
+        </p:txBody>
       </p:sp>
       <p:sp>
         <p:nvSpPr>
@@ -5743,7 +5480,7 @@
           <a:bodyPr wrap="square" rtlCol="0" anchor="ctr"/>
           <a:lstStyle/>
           <a:p>
-            <a:pPr algn="ctr" indent="0" marL="0">
+            <a:pPr marL="0" indent="0" algn="ctr">
               <a:buNone/>
             </a:pPr>
             <a:r>
@@ -5782,7 +5519,7 @@
           <a:bodyPr wrap="square" rtlCol="0" anchor="ctr"/>
           <a:lstStyle/>
           <a:p>
-            <a:pPr algn="ctr" indent="0" marL="0">
+            <a:pPr marL="0" indent="0" algn="ctr">
               <a:buNone/>
             </a:pPr>
             <a:r>
@@ -5799,7 +5536,7 @@
             <a:endParaRPr lang="en-US" sz="1000" dirty="0"/>
           </a:p>
           <a:p>
-            <a:pPr algn="ctr" indent="0" marL="0">
+            <a:pPr marL="0" indent="0" algn="ctr">
               <a:buNone/>
             </a:pPr>
             <a:r>
@@ -5836,6 +5573,13 @@
           </a:solidFill>
           <a:ln/>
         </p:spPr>
+        <p:txBody>
+          <a:bodyPr/>
+          <a:lstStyle/>
+          <a:p>
+            <a:endParaRPr lang="en-US"/>
+          </a:p>
+        </p:txBody>
       </p:sp>
       <p:sp>
         <p:nvSpPr>
@@ -5863,13 +5607,20 @@
             <a:prstDash val="solid"/>
           </a:ln>
           <a:effectLst>
-            <a:outerShdw sx="100000" sy="100000" kx="0" ky="0" algn="bl" rotWithShape="0" blurRad="1524" dist="508" dir="5400000">
+            <a:outerShdw blurRad="1524" dist="508" dir="5400000" algn="bl" rotWithShape="0">
               <a:srgbClr val="16324A">
                 <a:alpha val="25000"/>
               </a:srgbClr>
             </a:outerShdw>
           </a:effectLst>
         </p:spPr>
+        <p:txBody>
+          <a:bodyPr/>
+          <a:lstStyle/>
+          <a:p>
+            <a:endParaRPr lang="en-US"/>
+          </a:p>
+        </p:txBody>
       </p:sp>
       <p:sp>
         <p:nvSpPr>
@@ -5892,7 +5643,7 @@
           <a:bodyPr wrap="square" rtlCol="0" anchor="ctr"/>
           <a:lstStyle/>
           <a:p>
-            <a:pPr algn="ctr" indent="0" marL="0">
+            <a:pPr marL="0" indent="0" algn="ctr">
               <a:buNone/>
             </a:pPr>
             <a:r>
@@ -5931,7 +5682,7 @@
           <a:bodyPr wrap="square" rtlCol="0" anchor="ctr"/>
           <a:lstStyle/>
           <a:p>
-            <a:pPr algn="ctr" indent="0" marL="0">
+            <a:pPr marL="0" indent="0" algn="ctr">
               <a:buNone/>
             </a:pPr>
             <a:r>
@@ -5948,7 +5699,7 @@
             <a:endParaRPr lang="en-US" sz="1000" dirty="0"/>
           </a:p>
           <a:p>
-            <a:pPr algn="ctr" indent="0" marL="0">
+            <a:pPr marL="0" indent="0" algn="ctr">
               <a:buNone/>
             </a:pPr>
             <a:r>
@@ -5985,6 +5736,13 @@
           </a:solidFill>
           <a:ln/>
         </p:spPr>
+        <p:txBody>
+          <a:bodyPr/>
+          <a:lstStyle/>
+          <a:p>
+            <a:endParaRPr lang="en-US"/>
+          </a:p>
+        </p:txBody>
       </p:sp>
       <p:sp>
         <p:nvSpPr>
@@ -6012,13 +5770,20 @@
             <a:prstDash val="solid"/>
           </a:ln>
           <a:effectLst>
-            <a:outerShdw sx="100000" sy="100000" kx="0" ky="0" algn="bl" rotWithShape="0" blurRad="1524" dist="508" dir="5400000">
+            <a:outerShdw blurRad="1524" dist="508" dir="5400000" algn="bl" rotWithShape="0">
               <a:srgbClr val="16324A">
                 <a:alpha val="25000"/>
               </a:srgbClr>
             </a:outerShdw>
           </a:effectLst>
         </p:spPr>
+        <p:txBody>
+          <a:bodyPr/>
+          <a:lstStyle/>
+          <a:p>
+            <a:endParaRPr lang="en-US"/>
+          </a:p>
+        </p:txBody>
       </p:sp>
       <p:sp>
         <p:nvSpPr>
@@ -6041,7 +5806,7 @@
           <a:bodyPr wrap="square" rtlCol="0" anchor="ctr"/>
           <a:lstStyle/>
           <a:p>
-            <a:pPr algn="ctr" indent="0" marL="0">
+            <a:pPr marL="0" indent="0" algn="ctr">
               <a:buNone/>
             </a:pPr>
             <a:r>
@@ -6080,7 +5845,7 @@
           <a:bodyPr wrap="square" rtlCol="0" anchor="ctr"/>
           <a:lstStyle/>
           <a:p>
-            <a:pPr algn="ctr" indent="0" marL="0">
+            <a:pPr marL="0" indent="0" algn="ctr">
               <a:buNone/>
             </a:pPr>
             <a:r>
@@ -6097,7 +5862,7 @@
             <a:endParaRPr lang="en-US" sz="1000" dirty="0"/>
           </a:p>
           <a:p>
-            <a:pPr algn="ctr" indent="0" marL="0">
+            <a:pPr marL="0" indent="0" algn="ctr">
               <a:buNone/>
             </a:pPr>
             <a:r>
@@ -6134,6 +5899,13 @@
           </a:solidFill>
           <a:ln/>
         </p:spPr>
+        <p:txBody>
+          <a:bodyPr/>
+          <a:lstStyle/>
+          <a:p>
+            <a:endParaRPr lang="en-US"/>
+          </a:p>
+        </p:txBody>
       </p:sp>
       <p:sp>
         <p:nvSpPr>
@@ -6161,13 +5933,20 @@
             <a:prstDash val="solid"/>
           </a:ln>
           <a:effectLst>
-            <a:outerShdw sx="100000" sy="100000" kx="0" ky="0" algn="bl" rotWithShape="0" blurRad="1524" dist="508" dir="5400000">
+            <a:outerShdw blurRad="1524" dist="508" dir="5400000" algn="bl" rotWithShape="0">
               <a:srgbClr val="16324A">
                 <a:alpha val="25000"/>
               </a:srgbClr>
             </a:outerShdw>
           </a:effectLst>
         </p:spPr>
+        <p:txBody>
+          <a:bodyPr/>
+          <a:lstStyle/>
+          <a:p>
+            <a:endParaRPr lang="en-US"/>
+          </a:p>
+        </p:txBody>
       </p:sp>
       <p:sp>
         <p:nvSpPr>
@@ -6190,7 +5969,7 @@
           <a:bodyPr wrap="square" rtlCol="0" anchor="ctr"/>
           <a:lstStyle/>
           <a:p>
-            <a:pPr algn="ctr" indent="0" marL="0">
+            <a:pPr marL="0" indent="0" algn="ctr">
               <a:buNone/>
             </a:pPr>
             <a:r>
@@ -6229,7 +6008,7 @@
           <a:bodyPr wrap="square" rtlCol="0" anchor="ctr"/>
           <a:lstStyle/>
           <a:p>
-            <a:pPr algn="ctr" indent="0" marL="0">
+            <a:pPr marL="0" indent="0" algn="ctr">
               <a:buNone/>
             </a:pPr>
             <a:r>
@@ -6246,7 +6025,7 @@
             <a:endParaRPr lang="en-US" sz="1000" dirty="0"/>
           </a:p>
           <a:p>
-            <a:pPr algn="ctr" indent="0" marL="0">
+            <a:pPr marL="0" indent="0" algn="ctr">
               <a:buNone/>
             </a:pPr>
             <a:r>
@@ -6283,6 +6062,13 @@
           </a:solidFill>
           <a:ln/>
         </p:spPr>
+        <p:txBody>
+          <a:bodyPr/>
+          <a:lstStyle/>
+          <a:p>
+            <a:endParaRPr lang="en-US"/>
+          </a:p>
+        </p:txBody>
       </p:sp>
       <p:sp>
         <p:nvSpPr>
@@ -6310,13 +6096,20 @@
             <a:prstDash val="solid"/>
           </a:ln>
           <a:effectLst>
-            <a:outerShdw sx="100000" sy="100000" kx="0" ky="0" algn="bl" rotWithShape="0" blurRad="1524" dist="508" dir="5400000">
+            <a:outerShdw blurRad="1524" dist="508" dir="5400000" algn="bl" rotWithShape="0">
               <a:srgbClr val="16324A">
                 <a:alpha val="25000"/>
               </a:srgbClr>
             </a:outerShdw>
           </a:effectLst>
         </p:spPr>
+        <p:txBody>
+          <a:bodyPr/>
+          <a:lstStyle/>
+          <a:p>
+            <a:endParaRPr lang="en-US"/>
+          </a:p>
+        </p:txBody>
       </p:sp>
       <p:sp>
         <p:nvSpPr>
@@ -6339,7 +6132,7 @@
           <a:bodyPr wrap="square" rtlCol="0" anchor="ctr"/>
           <a:lstStyle/>
           <a:p>
-            <a:pPr algn="ctr" indent="0" marL="0">
+            <a:pPr marL="0" indent="0" algn="ctr">
               <a:buNone/>
             </a:pPr>
             <a:r>
@@ -6378,7 +6171,7 @@
           <a:bodyPr wrap="square" rtlCol="0" anchor="ctr"/>
           <a:lstStyle/>
           <a:p>
-            <a:pPr algn="ctr" indent="0" marL="0">
+            <a:pPr marL="0" indent="0" algn="ctr">
               <a:buNone/>
             </a:pPr>
             <a:r>
@@ -6415,6 +6208,13 @@
           </a:solidFill>
           <a:ln/>
         </p:spPr>
+        <p:txBody>
+          <a:bodyPr/>
+          <a:lstStyle/>
+          <a:p>
+            <a:endParaRPr lang="en-US"/>
+          </a:p>
+        </p:txBody>
       </p:sp>
       <p:sp>
         <p:nvSpPr>
@@ -6442,13 +6242,20 @@
             <a:prstDash val="solid"/>
           </a:ln>
           <a:effectLst>
-            <a:outerShdw sx="100000" sy="100000" kx="0" ky="0" algn="bl" rotWithShape="0" blurRad="1524" dist="508" dir="5400000">
+            <a:outerShdw blurRad="1524" dist="508" dir="5400000" algn="bl" rotWithShape="0">
               <a:srgbClr val="16324A">
                 <a:alpha val="25000"/>
               </a:srgbClr>
             </a:outerShdw>
           </a:effectLst>
         </p:spPr>
+        <p:txBody>
+          <a:bodyPr/>
+          <a:lstStyle/>
+          <a:p>
+            <a:endParaRPr lang="en-US"/>
+          </a:p>
+        </p:txBody>
       </p:sp>
       <p:sp>
         <p:nvSpPr>
@@ -6471,7 +6278,7 @@
           <a:bodyPr wrap="square" rtlCol="0" anchor="ctr"/>
           <a:lstStyle/>
           <a:p>
-            <a:pPr algn="ctr" indent="0" marL="0">
+            <a:pPr marL="0" indent="0" algn="ctr">
               <a:buNone/>
             </a:pPr>
             <a:r>
@@ -6510,7 +6317,7 @@
           <a:bodyPr wrap="square" rtlCol="0" anchor="ctr"/>
           <a:lstStyle/>
           <a:p>
-            <a:pPr algn="ctr" indent="0" marL="0">
+            <a:pPr marL="0" indent="0" algn="ctr">
               <a:buNone/>
             </a:pPr>
             <a:r>
@@ -6554,13 +6361,20 @@
             <a:prstDash val="solid"/>
           </a:ln>
           <a:effectLst>
-            <a:outerShdw sx="100000" sy="100000" kx="0" ky="0" algn="bl" rotWithShape="0" blurRad="1524" dist="508" dir="5400000">
+            <a:outerShdw blurRad="1524" dist="508" dir="5400000" algn="bl" rotWithShape="0">
               <a:srgbClr val="16324A">
                 <a:alpha val="25000"/>
               </a:srgbClr>
             </a:outerShdw>
           </a:effectLst>
         </p:spPr>
+        <p:txBody>
+          <a:bodyPr/>
+          <a:lstStyle/>
+          <a:p>
+            <a:endParaRPr lang="en-US"/>
+          </a:p>
+        </p:txBody>
       </p:sp>
       <p:sp>
         <p:nvSpPr>
@@ -6583,7 +6397,7 @@
           <a:bodyPr wrap="square" lIns="0" tIns="0" rIns="0" bIns="0" rtlCol="0" anchor="ctr"/>
           <a:lstStyle/>
           <a:p>
-            <a:pPr indent="0" marL="0">
+            <a:pPr marL="0" indent="0">
               <a:buNone/>
             </a:pPr>
             <a:r>
@@ -6702,6 +6516,7 @@
         <a:solidFill>
           <a:srgbClr val="FFFFFF"/>
         </a:solidFill>
+        <a:effectLst/>
       </p:bgPr>
     </p:bg>
     <p:spTree>
@@ -6739,7 +6554,7 @@
           <a:bodyPr wrap="square" lIns="0" tIns="0" rIns="0" bIns="0" rtlCol="0" anchor="ctr"/>
           <a:lstStyle/>
           <a:p>
-            <a:pPr indent="0" marL="0">
+            <a:pPr marL="0" indent="0">
               <a:buNone/>
             </a:pPr>
             <a:r>
@@ -6759,7 +6574,7 @@
       </p:sp>
       <p:graphicFrame>
         <p:nvGraphicFramePr>
-          <p:cNvPr id="3" name="Chart 0" descr=""/>
+          <p:cNvPr id="3" name="Chart 0"/>
           <p:cNvGraphicFramePr/>
           <p:nvPr/>
         </p:nvGraphicFramePr>
@@ -6767,9 +6582,9 @@
           <a:off x="566928" y="1188720"/>
           <a:ext cx="5760720" cy="4206240"/>
         </p:xfrm>
-        <a:graphic xmlns:a="http://schemas.openxmlformats.org/drawingml/2006/main">
+        <a:graphic>
           <a:graphicData uri="http://schemas.openxmlformats.org/drawingml/2006/chart">
-            <c:chart xmlns:c="http://schemas.openxmlformats.org/drawingml/2006/chart" r:id="rId1"/>
+            <c:chart xmlns:c="http://schemas.openxmlformats.org/drawingml/2006/chart" xmlns:r="http://schemas.openxmlformats.org/officeDocument/2006/relationships" r:id="rId3"/>
           </a:graphicData>
         </a:graphic>
       </p:graphicFrame>
@@ -6799,13 +6614,20 @@
             <a:prstDash val="solid"/>
           </a:ln>
           <a:effectLst>
-            <a:outerShdw sx="100000" sy="100000" kx="0" ky="0" algn="bl" rotWithShape="0" blurRad="1524" dist="508" dir="5400000">
+            <a:outerShdw blurRad="1524" dist="508" dir="5400000" algn="bl" rotWithShape="0">
               <a:srgbClr val="16324A">
                 <a:alpha val="25000"/>
               </a:srgbClr>
             </a:outerShdw>
           </a:effectLst>
         </p:spPr>
+        <p:txBody>
+          <a:bodyPr/>
+          <a:lstStyle/>
+          <a:p>
+            <a:endParaRPr lang="en-US"/>
+          </a:p>
+        </p:txBody>
       </p:sp>
       <p:sp>
         <p:nvSpPr>
@@ -6828,7 +6650,7 @@
           <a:bodyPr wrap="square" lIns="0" tIns="0" rIns="0" bIns="0" rtlCol="0" anchor="ctr"/>
           <a:lstStyle/>
           <a:p>
-            <a:pPr indent="0" marL="0">
+            <a:pPr marL="0" indent="0">
               <a:buNone/>
             </a:pPr>
             <a:r>
@@ -6867,7 +6689,7 @@
           <a:bodyPr wrap="square" lIns="0" tIns="0" rIns="0" bIns="0" rtlCol="0" anchor="ctr"/>
           <a:lstStyle/>
           <a:p>
-            <a:pPr indent="0" marL="0">
+            <a:pPr marL="0" indent="0">
               <a:buNone/>
             </a:pPr>
             <a:r>
@@ -6911,13 +6733,20 @@
             <a:prstDash val="solid"/>
           </a:ln>
           <a:effectLst>
-            <a:outerShdw sx="100000" sy="100000" kx="0" ky="0" algn="bl" rotWithShape="0" blurRad="1524" dist="508" dir="5400000">
+            <a:outerShdw blurRad="1524" dist="508" dir="5400000" algn="bl" rotWithShape="0">
               <a:srgbClr val="16324A">
                 <a:alpha val="25000"/>
               </a:srgbClr>
             </a:outerShdw>
           </a:effectLst>
         </p:spPr>
+        <p:txBody>
+          <a:bodyPr/>
+          <a:lstStyle/>
+          <a:p>
+            <a:endParaRPr lang="en-US"/>
+          </a:p>
+        </p:txBody>
       </p:sp>
       <p:sp>
         <p:nvSpPr>
@@ -6940,7 +6769,7 @@
           <a:bodyPr wrap="square" lIns="0" tIns="0" rIns="0" bIns="0" rtlCol="0" anchor="ctr"/>
           <a:lstStyle/>
           <a:p>
-            <a:pPr indent="0" marL="0">
+            <a:pPr marL="0" indent="0">
               <a:buNone/>
             </a:pPr>
             <a:r>
@@ -6979,7 +6808,7 @@
           <a:bodyPr wrap="square" lIns="0" tIns="0" rIns="0" bIns="0" rtlCol="0" anchor="ctr"/>
           <a:lstStyle/>
           <a:p>
-            <a:pPr indent="0" marL="0">
+            <a:pPr marL="0" indent="0">
               <a:buNone/>
             </a:pPr>
             <a:r>
@@ -7023,13 +6852,20 @@
             <a:prstDash val="solid"/>
           </a:ln>
           <a:effectLst>
-            <a:outerShdw sx="100000" sy="100000" kx="0" ky="0" algn="bl" rotWithShape="0" blurRad="1524" dist="508" dir="5400000">
+            <a:outerShdw blurRad="1524" dist="508" dir="5400000" algn="bl" rotWithShape="0">
               <a:srgbClr val="16324A">
                 <a:alpha val="25000"/>
               </a:srgbClr>
             </a:outerShdw>
           </a:effectLst>
         </p:spPr>
+        <p:txBody>
+          <a:bodyPr/>
+          <a:lstStyle/>
+          <a:p>
+            <a:endParaRPr lang="en-US"/>
+          </a:p>
+        </p:txBody>
       </p:sp>
       <p:sp>
         <p:nvSpPr>
@@ -7052,7 +6888,7 @@
           <a:bodyPr wrap="square" lIns="0" tIns="0" rIns="0" bIns="0" rtlCol="0" anchor="ctr"/>
           <a:lstStyle/>
           <a:p>
-            <a:pPr indent="0" marL="0">
+            <a:pPr marL="0" indent="0">
               <a:buNone/>
             </a:pPr>
             <a:r>
@@ -7091,7 +6927,7 @@
           <a:bodyPr wrap="square" lIns="0" tIns="0" rIns="0" bIns="0" rtlCol="0" anchor="ctr"/>
           <a:lstStyle/>
           <a:p>
-            <a:pPr indent="0" marL="0">
+            <a:pPr marL="0" indent="0">
               <a:buNone/>
             </a:pPr>
             <a:r>
@@ -7125,6 +6961,7 @@
         <a:solidFill>
           <a:srgbClr val="F4F6F9"/>
         </a:solidFill>
+        <a:effectLst/>
       </p:bgPr>
     </p:bg>
     <p:spTree>
@@ -7162,7 +6999,7 @@
           <a:bodyPr wrap="square" lIns="0" tIns="0" rIns="0" bIns="0" rtlCol="0" anchor="ctr"/>
           <a:lstStyle/>
           <a:p>
-            <a:pPr indent="0" marL="0">
+            <a:pPr marL="0" indent="0">
               <a:buNone/>
             </a:pPr>
             <a:r>
@@ -7206,13 +7043,20 @@
             <a:prstDash val="solid"/>
           </a:ln>
           <a:effectLst>
-            <a:outerShdw sx="100000" sy="100000" kx="0" ky="0" algn="bl" rotWithShape="0" blurRad="1524" dist="508" dir="5400000">
+            <a:outerShdw blurRad="1524" dist="508" dir="5400000" algn="bl" rotWithShape="0">
               <a:srgbClr val="16324A">
                 <a:alpha val="25000"/>
               </a:srgbClr>
             </a:outerShdw>
           </a:effectLst>
         </p:spPr>
+        <p:txBody>
+          <a:bodyPr/>
+          <a:lstStyle/>
+          <a:p>
+            <a:endParaRPr lang="en-US"/>
+          </a:p>
+        </p:txBody>
       </p:sp>
       <p:sp>
         <p:nvSpPr>
@@ -7233,6 +7077,13 @@
           </a:solidFill>
           <a:ln/>
         </p:spPr>
+        <p:txBody>
+          <a:bodyPr/>
+          <a:lstStyle/>
+          <a:p>
+            <a:endParaRPr lang="en-US"/>
+          </a:p>
+        </p:txBody>
       </p:sp>
       <p:sp>
         <p:nvSpPr>
@@ -7255,7 +7106,7 @@
           <a:bodyPr wrap="square" lIns="0" tIns="0" rIns="0" bIns="0" rtlCol="0" anchor="ctr"/>
           <a:lstStyle/>
           <a:p>
-            <a:pPr algn="ctr" indent="0" marL="0">
+            <a:pPr marL="0" indent="0" algn="ctr">
               <a:buNone/>
             </a:pPr>
             <a:r>
@@ -7294,7 +7145,7 @@
           <a:bodyPr wrap="square" lIns="0" tIns="0" rIns="0" bIns="0" rtlCol="0" anchor="ctr"/>
           <a:lstStyle/>
           <a:p>
-            <a:pPr indent="0" marL="0">
+            <a:pPr marL="0" indent="0">
               <a:buNone/>
             </a:pPr>
             <a:r>
@@ -7333,7 +7184,7 @@
           <a:bodyPr wrap="square" lIns="0" tIns="0" rIns="0" bIns="0" rtlCol="0" anchor="ctr"/>
           <a:lstStyle/>
           <a:p>
-            <a:pPr indent="0" marL="0">
+            <a:pPr marL="0" indent="0">
               <a:buNone/>
             </a:pPr>
             <a:r>
@@ -7377,13 +7228,20 @@
             <a:prstDash val="solid"/>
           </a:ln>
           <a:effectLst>
-            <a:outerShdw sx="100000" sy="100000" kx="0" ky="0" algn="bl" rotWithShape="0" blurRad="1524" dist="508" dir="5400000">
+            <a:outerShdw blurRad="1524" dist="508" dir="5400000" algn="bl" rotWithShape="0">
               <a:srgbClr val="16324A">
                 <a:alpha val="25000"/>
               </a:srgbClr>
             </a:outerShdw>
           </a:effectLst>
         </p:spPr>
+        <p:txBody>
+          <a:bodyPr/>
+          <a:lstStyle/>
+          <a:p>
+            <a:endParaRPr lang="en-US"/>
+          </a:p>
+        </p:txBody>
       </p:sp>
       <p:sp>
         <p:nvSpPr>
@@ -7404,6 +7262,13 @@
           </a:solidFill>
           <a:ln/>
         </p:spPr>
+        <p:txBody>
+          <a:bodyPr/>
+          <a:lstStyle/>
+          <a:p>
+            <a:endParaRPr lang="en-US"/>
+          </a:p>
+        </p:txBody>
       </p:sp>
       <p:sp>
         <p:nvSpPr>
@@ -7426,7 +7291,7 @@
           <a:bodyPr wrap="square" lIns="0" tIns="0" rIns="0" bIns="0" rtlCol="0" anchor="ctr"/>
           <a:lstStyle/>
           <a:p>
-            <a:pPr algn="ctr" indent="0" marL="0">
+            <a:pPr marL="0" indent="0" algn="ctr">
               <a:buNone/>
             </a:pPr>
             <a:r>
@@ -7465,7 +7330,7 @@
           <a:bodyPr wrap="square" lIns="0" tIns="0" rIns="0" bIns="0" rtlCol="0" anchor="ctr"/>
           <a:lstStyle/>
           <a:p>
-            <a:pPr indent="0" marL="0">
+            <a:pPr marL="0" indent="0">
               <a:buNone/>
             </a:pPr>
             <a:r>
@@ -7504,7 +7369,7 @@
           <a:bodyPr wrap="square" lIns="0" tIns="0" rIns="0" bIns="0" rtlCol="0" anchor="ctr"/>
           <a:lstStyle/>
           <a:p>
-            <a:pPr indent="0" marL="0">
+            <a:pPr marL="0" indent="0">
               <a:buNone/>
             </a:pPr>
             <a:r>
@@ -7548,13 +7413,20 @@
             <a:prstDash val="solid"/>
           </a:ln>
           <a:effectLst>
-            <a:outerShdw sx="100000" sy="100000" kx="0" ky="0" algn="bl" rotWithShape="0" blurRad="1524" dist="508" dir="5400000">
+            <a:outerShdw blurRad="1524" dist="508" dir="5400000" algn="bl" rotWithShape="0">
               <a:srgbClr val="16324A">
                 <a:alpha val="25000"/>
               </a:srgbClr>
             </a:outerShdw>
           </a:effectLst>
         </p:spPr>
+        <p:txBody>
+          <a:bodyPr/>
+          <a:lstStyle/>
+          <a:p>
+            <a:endParaRPr lang="en-US"/>
+          </a:p>
+        </p:txBody>
       </p:sp>
       <p:sp>
         <p:nvSpPr>
@@ -7575,6 +7447,13 @@
           </a:solidFill>
           <a:ln/>
         </p:spPr>
+        <p:txBody>
+          <a:bodyPr/>
+          <a:lstStyle/>
+          <a:p>
+            <a:endParaRPr lang="en-US"/>
+          </a:p>
+        </p:txBody>
       </p:sp>
       <p:sp>
         <p:nvSpPr>
@@ -7597,7 +7476,7 @@
           <a:bodyPr wrap="square" lIns="0" tIns="0" rIns="0" bIns="0" rtlCol="0" anchor="ctr"/>
           <a:lstStyle/>
           <a:p>
-            <a:pPr algn="ctr" indent="0" marL="0">
+            <a:pPr marL="0" indent="0" algn="ctr">
               <a:buNone/>
             </a:pPr>
             <a:r>
@@ -7636,7 +7515,7 @@
           <a:bodyPr wrap="square" lIns="0" tIns="0" rIns="0" bIns="0" rtlCol="0" anchor="ctr"/>
           <a:lstStyle/>
           <a:p>
-            <a:pPr indent="0" marL="0">
+            <a:pPr marL="0" indent="0">
               <a:buNone/>
             </a:pPr>
             <a:r>
@@ -7675,7 +7554,7 @@
           <a:bodyPr wrap="square" lIns="0" tIns="0" rIns="0" bIns="0" rtlCol="0" anchor="ctr"/>
           <a:lstStyle/>
           <a:p>
-            <a:pPr indent="0" marL="0">
+            <a:pPr marL="0" indent="0">
               <a:buNone/>
             </a:pPr>
             <a:r>
@@ -7719,13 +7598,20 @@
             <a:prstDash val="solid"/>
           </a:ln>
           <a:effectLst>
-            <a:outerShdw sx="100000" sy="100000" kx="0" ky="0" algn="bl" rotWithShape="0" blurRad="1524" dist="508" dir="5400000">
+            <a:outerShdw blurRad="1524" dist="508" dir="5400000" algn="bl" rotWithShape="0">
               <a:srgbClr val="16324A">
                 <a:alpha val="25000"/>
               </a:srgbClr>
             </a:outerShdw>
           </a:effectLst>
         </p:spPr>
+        <p:txBody>
+          <a:bodyPr/>
+          <a:lstStyle/>
+          <a:p>
+            <a:endParaRPr lang="en-US"/>
+          </a:p>
+        </p:txBody>
       </p:sp>
       <p:sp>
         <p:nvSpPr>
@@ -7746,6 +7632,13 @@
           </a:solidFill>
           <a:ln/>
         </p:spPr>
+        <p:txBody>
+          <a:bodyPr/>
+          <a:lstStyle/>
+          <a:p>
+            <a:endParaRPr lang="en-US"/>
+          </a:p>
+        </p:txBody>
       </p:sp>
       <p:sp>
         <p:nvSpPr>
@@ -7768,7 +7661,7 @@
           <a:bodyPr wrap="square" lIns="0" tIns="0" rIns="0" bIns="0" rtlCol="0" anchor="ctr"/>
           <a:lstStyle/>
           <a:p>
-            <a:pPr algn="ctr" indent="0" marL="0">
+            <a:pPr marL="0" indent="0" algn="ctr">
               <a:buNone/>
             </a:pPr>
             <a:r>
@@ -7807,7 +7700,7 @@
           <a:bodyPr wrap="square" lIns="0" tIns="0" rIns="0" bIns="0" rtlCol="0" anchor="ctr"/>
           <a:lstStyle/>
           <a:p>
-            <a:pPr indent="0" marL="0">
+            <a:pPr marL="0" indent="0">
               <a:buNone/>
             </a:pPr>
             <a:r>
@@ -7846,7 +7739,7 @@
           <a:bodyPr wrap="square" lIns="0" tIns="0" rIns="0" bIns="0" rtlCol="0" anchor="ctr"/>
           <a:lstStyle/>
           <a:p>
-            <a:pPr indent="0" marL="0">
+            <a:pPr marL="0" indent="0">
               <a:buNone/>
             </a:pPr>
             <a:r>
@@ -7880,6 +7773,7 @@
         <a:solidFill>
           <a:srgbClr val="FFFFFF"/>
         </a:solidFill>
+        <a:effectLst/>
       </p:bgPr>
     </p:bg>
     <p:spTree>
@@ -7917,7 +7811,7 @@
           <a:bodyPr wrap="square" lIns="0" tIns="0" rIns="0" bIns="0" rtlCol="0" anchor="ctr"/>
           <a:lstStyle/>
           <a:p>
-            <a:pPr indent="0" marL="0">
+            <a:pPr marL="0" indent="0">
               <a:buNone/>
             </a:pPr>
             <a:r>
@@ -7961,13 +7855,20 @@
             <a:prstDash val="solid"/>
           </a:ln>
           <a:effectLst>
-            <a:outerShdw sx="100000" sy="100000" kx="0" ky="0" algn="bl" rotWithShape="0" blurRad="1524" dist="508" dir="5400000">
+            <a:outerShdw blurRad="1524" dist="508" dir="5400000" algn="bl" rotWithShape="0">
               <a:srgbClr val="16324A">
                 <a:alpha val="25000"/>
               </a:srgbClr>
             </a:outerShdw>
           </a:effectLst>
         </p:spPr>
+        <p:txBody>
+          <a:bodyPr/>
+          <a:lstStyle/>
+          <a:p>
+            <a:endParaRPr lang="en-US"/>
+          </a:p>
+        </p:txBody>
       </p:sp>
       <p:sp>
         <p:nvSpPr>
@@ -7990,6 +7891,13 @@
           </a:solidFill>
           <a:ln/>
         </p:spPr>
+        <p:txBody>
+          <a:bodyPr/>
+          <a:lstStyle/>
+          <a:p>
+            <a:endParaRPr lang="en-US"/>
+          </a:p>
+        </p:txBody>
       </p:sp>
       <p:sp>
         <p:nvSpPr>
@@ -8012,7 +7920,7 @@
           <a:bodyPr wrap="square" rtlCol="0" anchor="ctr"/>
           <a:lstStyle/>
           <a:p>
-            <a:pPr algn="ctr" indent="0" marL="0">
+            <a:pPr marL="0" indent="0" algn="ctr">
               <a:buNone/>
             </a:pPr>
             <a:r>
@@ -8051,7 +7959,7 @@
           <a:bodyPr wrap="square" rtlCol="0" anchor="ctr"/>
           <a:lstStyle/>
           <a:p>
-            <a:pPr indent="0" marL="0">
+            <a:pPr marL="0" indent="0">
               <a:buNone/>
             </a:pPr>
             <a:r>
@@ -8090,7 +7998,7 @@
           <a:bodyPr wrap="square" rtlCol="0" anchor="ctr"/>
           <a:lstStyle/>
           <a:p>
-            <a:pPr algn="ctr" indent="0" marL="0">
+            <a:pPr marL="0" indent="0" algn="ctr">
               <a:buNone/>
             </a:pPr>
             <a:r>
@@ -8134,13 +8042,20 @@
             <a:prstDash val="solid"/>
           </a:ln>
           <a:effectLst>
-            <a:outerShdw sx="100000" sy="100000" kx="0" ky="0" algn="bl" rotWithShape="0" blurRad="1524" dist="508" dir="5400000">
+            <a:outerShdw blurRad="1524" dist="508" dir="5400000" algn="bl" rotWithShape="0">
               <a:srgbClr val="16324A">
                 <a:alpha val="25000"/>
               </a:srgbClr>
             </a:outerShdw>
           </a:effectLst>
         </p:spPr>
+        <p:txBody>
+          <a:bodyPr/>
+          <a:lstStyle/>
+          <a:p>
+            <a:endParaRPr lang="en-US"/>
+          </a:p>
+        </p:txBody>
       </p:sp>
       <p:sp>
         <p:nvSpPr>
@@ -8166,6 +8081,13 @@
             <a:prstDash val="solid"/>
           </a:ln>
         </p:spPr>
+        <p:txBody>
+          <a:bodyPr/>
+          <a:lstStyle/>
+          <a:p>
+            <a:endParaRPr lang="en-US"/>
+          </a:p>
+        </p:txBody>
       </p:sp>
       <p:sp>
         <p:nvSpPr>
@@ -8188,7 +8110,7 @@
           <a:bodyPr wrap="square" rtlCol="0" anchor="ctr"/>
           <a:lstStyle/>
           <a:p>
-            <a:pPr algn="ctr" indent="0" marL="0">
+            <a:pPr marL="0" indent="0" algn="ctr">
               <a:buNone/>
             </a:pPr>
             <a:r>
@@ -8227,7 +8149,7 @@
           <a:bodyPr wrap="square" rtlCol="0" anchor="ctr"/>
           <a:lstStyle/>
           <a:p>
-            <a:pPr indent="0" marL="0">
+            <a:pPr marL="0" indent="0">
               <a:buNone/>
             </a:pPr>
             <a:r>
@@ -8266,7 +8188,7 @@
           <a:bodyPr wrap="square" rtlCol="0" anchor="ctr"/>
           <a:lstStyle/>
           <a:p>
-            <a:pPr algn="ctr" indent="0" marL="0">
+            <a:pPr marL="0" indent="0" algn="ctr">
               <a:buNone/>
             </a:pPr>
             <a:r>
@@ -8310,13 +8232,20 @@
             <a:prstDash val="solid"/>
           </a:ln>
           <a:effectLst>
-            <a:outerShdw sx="100000" sy="100000" kx="0" ky="0" algn="bl" rotWithShape="0" blurRad="1524" dist="508" dir="5400000">
+            <a:outerShdw blurRad="1524" dist="508" dir="5400000" algn="bl" rotWithShape="0">
               <a:srgbClr val="16324A">
                 <a:alpha val="25000"/>
               </a:srgbClr>
             </a:outerShdw>
           </a:effectLst>
         </p:spPr>
+        <p:txBody>
+          <a:bodyPr/>
+          <a:lstStyle/>
+          <a:p>
+            <a:endParaRPr lang="en-US"/>
+          </a:p>
+        </p:txBody>
       </p:sp>
       <p:sp>
         <p:nvSpPr>
@@ -8342,6 +8271,13 @@
             <a:prstDash val="solid"/>
           </a:ln>
         </p:spPr>
+        <p:txBody>
+          <a:bodyPr/>
+          <a:lstStyle/>
+          <a:p>
+            <a:endParaRPr lang="en-US"/>
+          </a:p>
+        </p:txBody>
       </p:sp>
       <p:sp>
         <p:nvSpPr>
@@ -8364,7 +8300,7 @@
           <a:bodyPr wrap="square" rtlCol="0" anchor="ctr"/>
           <a:lstStyle/>
           <a:p>
-            <a:pPr algn="ctr" indent="0" marL="0">
+            <a:pPr marL="0" indent="0" algn="ctr">
               <a:buNone/>
             </a:pPr>
             <a:r>
@@ -8403,7 +8339,7 @@
           <a:bodyPr wrap="square" rtlCol="0" anchor="ctr"/>
           <a:lstStyle/>
           <a:p>
-            <a:pPr indent="0" marL="0">
+            <a:pPr marL="0" indent="0">
               <a:buNone/>
             </a:pPr>
             <a:r>
@@ -8442,7 +8378,7 @@
           <a:bodyPr wrap="square" rtlCol="0" anchor="ctr"/>
           <a:lstStyle/>
           <a:p>
-            <a:pPr algn="ctr" indent="0" marL="0">
+            <a:pPr marL="0" indent="0" algn="ctr">
               <a:buNone/>
             </a:pPr>
             <a:r>
@@ -8486,13 +8422,20 @@
             <a:prstDash val="solid"/>
           </a:ln>
           <a:effectLst>
-            <a:outerShdw sx="100000" sy="100000" kx="0" ky="0" algn="bl" rotWithShape="0" blurRad="1524" dist="508" dir="5400000">
+            <a:outerShdw blurRad="1524" dist="508" dir="5400000" algn="bl" rotWithShape="0">
               <a:srgbClr val="16324A">
                 <a:alpha val="25000"/>
               </a:srgbClr>
             </a:outerShdw>
           </a:effectLst>
         </p:spPr>
+        <p:txBody>
+          <a:bodyPr/>
+          <a:lstStyle/>
+          <a:p>
+            <a:endParaRPr lang="en-US"/>
+          </a:p>
+        </p:txBody>
       </p:sp>
       <p:sp>
         <p:nvSpPr>
@@ -8515,7 +8458,7 @@
           <a:bodyPr wrap="square" lIns="0" tIns="0" rIns="0" bIns="0" rtlCol="0" anchor="ctr"/>
           <a:lstStyle/>
           <a:p>
-            <a:pPr indent="0" marL="0">
+            <a:pPr marL="0" indent="0">
               <a:buNone/>
             </a:pPr>
             <a:r>
@@ -8549,6 +8492,7 @@
         <a:solidFill>
           <a:srgbClr val="F4F6F9"/>
         </a:solidFill>
+        <a:effectLst/>
       </p:bgPr>
     </p:bg>
     <p:spTree>
@@ -8586,7 +8530,7 @@
           <a:bodyPr wrap="square" lIns="0" tIns="0" rIns="0" bIns="0" rtlCol="0" anchor="ctr"/>
           <a:lstStyle/>
           <a:p>
-            <a:pPr indent="0" marL="0">
+            <a:pPr marL="0" indent="0">
               <a:buNone/>
             </a:pPr>
             <a:r>
@@ -8630,13 +8574,20 @@
             <a:prstDash val="solid"/>
           </a:ln>
           <a:effectLst>
-            <a:outerShdw sx="100000" sy="100000" kx="0" ky="0" algn="bl" rotWithShape="0" blurRad="1524" dist="508" dir="5400000">
+            <a:outerShdw blurRad="1524" dist="508" dir="5400000" algn="bl" rotWithShape="0">
               <a:srgbClr val="16324A">
                 <a:alpha val="25000"/>
               </a:srgbClr>
             </a:outerShdw>
           </a:effectLst>
         </p:spPr>
+        <p:txBody>
+          <a:bodyPr/>
+          <a:lstStyle/>
+          <a:p>
+            <a:endParaRPr lang="en-US"/>
+          </a:p>
+        </p:txBody>
       </p:sp>
       <p:sp>
         <p:nvSpPr>
@@ -8659,7 +8610,7 @@
           <a:bodyPr wrap="square" lIns="0" tIns="0" rIns="0" bIns="0" rtlCol="0" anchor="ctr"/>
           <a:lstStyle/>
           <a:p>
-            <a:pPr indent="0" marL="0">
+            <a:pPr marL="0" indent="0">
               <a:buNone/>
             </a:pPr>
             <a:r>
@@ -8703,13 +8654,20 @@
             <a:prstDash val="solid"/>
           </a:ln>
           <a:effectLst>
-            <a:outerShdw sx="100000" sy="100000" kx="0" ky="0" algn="bl" rotWithShape="0" blurRad="1524" dist="508" dir="5400000">
+            <a:outerShdw blurRad="1524" dist="508" dir="5400000" algn="bl" rotWithShape="0">
               <a:srgbClr val="16324A">
                 <a:alpha val="25000"/>
               </a:srgbClr>
             </a:outerShdw>
           </a:effectLst>
         </p:spPr>
+        <p:txBody>
+          <a:bodyPr/>
+          <a:lstStyle/>
+          <a:p>
+            <a:endParaRPr lang="en-US"/>
+          </a:p>
+        </p:txBody>
       </p:sp>
       <p:sp>
         <p:nvSpPr>
@@ -8732,7 +8690,7 @@
           <a:bodyPr wrap="square" lIns="0" tIns="0" rIns="0" bIns="0" rtlCol="0" anchor="ctr"/>
           <a:lstStyle/>
           <a:p>
-            <a:pPr indent="0" marL="0">
+            <a:pPr marL="0" indent="0">
               <a:buNone/>
             </a:pPr>
             <a:r>
@@ -8771,7 +8729,7 @@
           <a:bodyPr wrap="square" lIns="0" tIns="0" rIns="0" bIns="0" rtlCol="0" anchor="ctr"/>
           <a:lstStyle/>
           <a:p>
-            <a:pPr indent="0" marL="0">
+            <a:pPr marL="0" indent="0">
               <a:buNone/>
             </a:pPr>
             <a:r>
@@ -8810,6 +8768,13 @@
           </a:solidFill>
           <a:ln/>
         </p:spPr>
+        <p:txBody>
+          <a:bodyPr/>
+          <a:lstStyle/>
+          <a:p>
+            <a:endParaRPr lang="en-US"/>
+          </a:p>
+        </p:txBody>
       </p:sp>
       <p:sp>
         <p:nvSpPr>
@@ -8832,7 +8797,7 @@
           <a:bodyPr wrap="square" lIns="0" tIns="0" rIns="0" bIns="0" rtlCol="0" anchor="ctr"/>
           <a:lstStyle/>
           <a:p>
-            <a:pPr indent="0" marL="0">
+            <a:pPr marL="0" indent="0">
               <a:buNone/>
             </a:pPr>
             <a:r>
@@ -8876,13 +8841,20 @@
             <a:prstDash val="solid"/>
           </a:ln>
           <a:effectLst>
-            <a:outerShdw sx="100000" sy="100000" kx="0" ky="0" algn="bl" rotWithShape="0" blurRad="1524" dist="508" dir="5400000">
+            <a:outerShdw blurRad="1524" dist="508" dir="5400000" algn="bl" rotWithShape="0">
               <a:srgbClr val="16324A">
                 <a:alpha val="25000"/>
               </a:srgbClr>
             </a:outerShdw>
           </a:effectLst>
         </p:spPr>
+        <p:txBody>
+          <a:bodyPr/>
+          <a:lstStyle/>
+          <a:p>
+            <a:endParaRPr lang="en-US"/>
+          </a:p>
+        </p:txBody>
       </p:sp>
       <p:sp>
         <p:nvSpPr>
@@ -8905,7 +8877,7 @@
           <a:bodyPr wrap="square" lIns="0" tIns="0" rIns="0" bIns="0" rtlCol="0" anchor="ctr"/>
           <a:lstStyle/>
           <a:p>
-            <a:pPr indent="0" marL="0">
+            <a:pPr marL="0" indent="0">
               <a:buNone/>
             </a:pPr>
             <a:r>
@@ -8944,7 +8916,7 @@
           <a:bodyPr wrap="square" lIns="0" tIns="0" rIns="0" bIns="0" rtlCol="0" anchor="ctr"/>
           <a:lstStyle/>
           <a:p>
-            <a:pPr indent="0" marL="0">
+            <a:pPr marL="0" indent="0">
               <a:buNone/>
             </a:pPr>
             <a:r>
@@ -8983,6 +8955,13 @@
           </a:solidFill>
           <a:ln/>
         </p:spPr>
+        <p:txBody>
+          <a:bodyPr/>
+          <a:lstStyle/>
+          <a:p>
+            <a:endParaRPr lang="en-US"/>
+          </a:p>
+        </p:txBody>
       </p:sp>
       <p:sp>
         <p:nvSpPr>
@@ -9005,7 +8984,7 @@
           <a:bodyPr wrap="square" lIns="0" tIns="0" rIns="0" bIns="0" rtlCol="0" anchor="ctr"/>
           <a:lstStyle/>
           <a:p>
-            <a:pPr indent="0" marL="0">
+            <a:pPr marL="0" indent="0">
               <a:buNone/>
             </a:pPr>
             <a:r>
@@ -9039,6 +9018,7 @@
         <a:solidFill>
           <a:srgbClr val="FFFFFF"/>
         </a:solidFill>
+        <a:effectLst/>
       </p:bgPr>
     </p:bg>
     <p:spTree>
@@ -9076,7 +9056,7 @@
           <a:bodyPr wrap="square" lIns="0" tIns="0" rIns="0" bIns="0" rtlCol="0" anchor="ctr"/>
           <a:lstStyle/>
           <a:p>
-            <a:pPr indent="0" marL="0">
+            <a:pPr marL="0" indent="0">
               <a:buNone/>
             </a:pPr>
             <a:r>
@@ -9120,13 +9100,20 @@
             <a:prstDash val="solid"/>
           </a:ln>
           <a:effectLst>
-            <a:outerShdw sx="100000" sy="100000" kx="0" ky="0" algn="bl" rotWithShape="0" blurRad="1524" dist="508" dir="5400000">
+            <a:outerShdw blurRad="1524" dist="508" dir="5400000" algn="bl" rotWithShape="0">
               <a:srgbClr val="16324A">
                 <a:alpha val="25000"/>
               </a:srgbClr>
             </a:outerShdw>
           </a:effectLst>
         </p:spPr>
+        <p:txBody>
+          <a:bodyPr/>
+          <a:lstStyle/>
+          <a:p>
+            <a:endParaRPr lang="en-US"/>
+          </a:p>
+        </p:txBody>
       </p:sp>
       <p:sp>
         <p:nvSpPr>
@@ -9149,6 +9136,13 @@
           </a:solidFill>
           <a:ln/>
         </p:spPr>
+        <p:txBody>
+          <a:bodyPr/>
+          <a:lstStyle/>
+          <a:p>
+            <a:endParaRPr lang="en-US"/>
+          </a:p>
+        </p:txBody>
       </p:sp>
       <p:sp>
         <p:nvSpPr>
@@ -9171,7 +9165,7 @@
           <a:bodyPr wrap="square" lIns="0" tIns="0" rIns="0" bIns="0" rtlCol="0" anchor="ctr"/>
           <a:lstStyle/>
           <a:p>
-            <a:pPr indent="0" marL="0">
+            <a:pPr marL="0" indent="0">
               <a:buNone/>
             </a:pPr>
             <a:r>
@@ -9215,6 +9209,13 @@
             <a:prstDash val="solid"/>
           </a:ln>
         </p:spPr>
+        <p:txBody>
+          <a:bodyPr/>
+          <a:lstStyle/>
+          <a:p>
+            <a:endParaRPr lang="en-US"/>
+          </a:p>
+        </p:txBody>
       </p:sp>
       <p:sp>
         <p:nvSpPr>
@@ -9237,7 +9238,7 @@
           <a:bodyPr wrap="square" lIns="0" tIns="0" rIns="0" bIns="0" rtlCol="0" anchor="ctr"/>
           <a:lstStyle/>
           <a:p>
-            <a:pPr indent="0" marL="0">
+            <a:pPr marL="0" indent="0">
               <a:buNone/>
             </a:pPr>
             <a:r>
@@ -9281,6 +9282,13 @@
             <a:prstDash val="solid"/>
           </a:ln>
         </p:spPr>
+        <p:txBody>
+          <a:bodyPr/>
+          <a:lstStyle/>
+          <a:p>
+            <a:endParaRPr lang="en-US"/>
+          </a:p>
+        </p:txBody>
       </p:sp>
       <p:sp>
         <p:nvSpPr>
@@ -9303,7 +9311,7 @@
           <a:bodyPr wrap="square" lIns="0" tIns="0" rIns="0" bIns="0" rtlCol="0" anchor="ctr"/>
           <a:lstStyle/>
           <a:p>
-            <a:pPr indent="0" marL="0">
+            <a:pPr marL="0" indent="0">
               <a:buNone/>
             </a:pPr>
             <a:r>
@@ -9347,6 +9355,13 @@
             <a:prstDash val="solid"/>
           </a:ln>
         </p:spPr>
+        <p:txBody>
+          <a:bodyPr/>
+          <a:lstStyle/>
+          <a:p>
+            <a:endParaRPr lang="en-US"/>
+          </a:p>
+        </p:txBody>
       </p:sp>
       <p:sp>
         <p:nvSpPr>
@@ -9369,7 +9384,7 @@
           <a:bodyPr wrap="square" rtlCol="0" anchor="ctr"/>
           <a:lstStyle/>
           <a:p>
-            <a:pPr algn="ctr" indent="0" marL="0">
+            <a:pPr marL="0" indent="0" algn="ctr">
               <a:buNone/>
             </a:pPr>
             <a:r>
@@ -9413,6 +9428,13 @@
             <a:prstDash val="solid"/>
           </a:ln>
         </p:spPr>
+        <p:txBody>
+          <a:bodyPr/>
+          <a:lstStyle/>
+          <a:p>
+            <a:endParaRPr lang="en-US"/>
+          </a:p>
+        </p:txBody>
       </p:sp>
       <p:sp>
         <p:nvSpPr>
@@ -9440,6 +9462,13 @@
             <a:prstDash val="solid"/>
           </a:ln>
         </p:spPr>
+        <p:txBody>
+          <a:bodyPr/>
+          <a:lstStyle/>
+          <a:p>
+            <a:endParaRPr lang="en-US"/>
+          </a:p>
+        </p:txBody>
       </p:sp>
       <p:sp>
         <p:nvSpPr>
@@ -9467,6 +9496,13 @@
             <a:prstDash val="solid"/>
           </a:ln>
         </p:spPr>
+        <p:txBody>
+          <a:bodyPr/>
+          <a:lstStyle/>
+          <a:p>
+            <a:endParaRPr lang="en-US"/>
+          </a:p>
+        </p:txBody>
       </p:sp>
       <p:sp>
         <p:nvSpPr>
@@ -9489,7 +9525,7 @@
           <a:bodyPr wrap="square" rtlCol="0" anchor="ctr"/>
           <a:lstStyle/>
           <a:p>
-            <a:pPr algn="ctr" indent="0" marL="0">
+            <a:pPr marL="0" indent="0" algn="ctr">
               <a:buNone/>
             </a:pPr>
             <a:r>
@@ -9533,13 +9569,20 @@
             <a:prstDash val="solid"/>
           </a:ln>
           <a:effectLst>
-            <a:outerShdw sx="100000" sy="100000" kx="0" ky="0" algn="bl" rotWithShape="0" blurRad="1524" dist="508" dir="5400000">
+            <a:outerShdw blurRad="1524" dist="508" dir="5400000" algn="bl" rotWithShape="0">
               <a:srgbClr val="16324A">
                 <a:alpha val="25000"/>
               </a:srgbClr>
             </a:outerShdw>
           </a:effectLst>
         </p:spPr>
+        <p:txBody>
+          <a:bodyPr/>
+          <a:lstStyle/>
+          <a:p>
+            <a:endParaRPr lang="en-US"/>
+          </a:p>
+        </p:txBody>
       </p:sp>
       <p:sp>
         <p:nvSpPr>
@@ -9562,7 +9605,7 @@
           <a:bodyPr wrap="square" lIns="0" tIns="0" rIns="0" bIns="0" rtlCol="0" anchor="ctr"/>
           <a:lstStyle/>
           <a:p>
-            <a:pPr indent="0" marL="0">
+            <a:pPr marL="0" indent="0">
               <a:buNone/>
             </a:pPr>
             <a:r>
@@ -9601,7 +9644,7 @@
           <a:bodyPr wrap="square" lIns="0" tIns="0" rIns="0" bIns="0" rtlCol="0" anchor="ctr"/>
           <a:lstStyle/>
           <a:p>
-            <a:pPr indent="0" marL="0">
+            <a:pPr marL="0" indent="0">
               <a:buNone/>
             </a:pPr>
             <a:r>
@@ -9645,13 +9688,20 @@
             <a:prstDash val="solid"/>
           </a:ln>
           <a:effectLst>
-            <a:outerShdw sx="100000" sy="100000" kx="0" ky="0" algn="bl" rotWithShape="0" blurRad="1524" dist="508" dir="5400000">
+            <a:outerShdw blurRad="1524" dist="508" dir="5400000" algn="bl" rotWithShape="0">
               <a:srgbClr val="16324A">
                 <a:alpha val="25000"/>
               </a:srgbClr>
             </a:outerShdw>
           </a:effectLst>
         </p:spPr>
+        <p:txBody>
+          <a:bodyPr/>
+          <a:lstStyle/>
+          <a:p>
+            <a:endParaRPr lang="en-US"/>
+          </a:p>
+        </p:txBody>
       </p:sp>
       <p:sp>
         <p:nvSpPr>
@@ -9674,7 +9724,7 @@
           <a:bodyPr wrap="square" lIns="0" tIns="0" rIns="0" bIns="0" rtlCol="0" anchor="ctr"/>
           <a:lstStyle/>
           <a:p>
-            <a:pPr indent="0" marL="0">
+            <a:pPr marL="0" indent="0">
               <a:buNone/>
             </a:pPr>
             <a:r>
@@ -9713,7 +9763,7 @@
           <a:bodyPr wrap="square" lIns="0" tIns="0" rIns="0" bIns="0" rtlCol="0" anchor="ctr"/>
           <a:lstStyle/>
           <a:p>
-            <a:pPr indent="0" marL="0">
+            <a:pPr marL="0" indent="0">
               <a:buNone/>
             </a:pPr>
             <a:r>
@@ -9757,13 +9807,20 @@
             <a:prstDash val="solid"/>
           </a:ln>
           <a:effectLst>
-            <a:outerShdw sx="100000" sy="100000" kx="0" ky="0" algn="bl" rotWithShape="0" blurRad="1524" dist="508" dir="5400000">
+            <a:outerShdw blurRad="1524" dist="508" dir="5400000" algn="bl" rotWithShape="0">
               <a:srgbClr val="16324A">
                 <a:alpha val="25000"/>
               </a:srgbClr>
             </a:outerShdw>
           </a:effectLst>
         </p:spPr>
+        <p:txBody>
+          <a:bodyPr/>
+          <a:lstStyle/>
+          <a:p>
+            <a:endParaRPr lang="en-US"/>
+          </a:p>
+        </p:txBody>
       </p:sp>
       <p:sp>
         <p:nvSpPr>
@@ -9786,7 +9843,7 @@
           <a:bodyPr wrap="square" lIns="0" tIns="0" rIns="0" bIns="0" rtlCol="0" anchor="ctr"/>
           <a:lstStyle/>
           <a:p>
-            <a:pPr indent="0" marL="0">
+            <a:pPr marL="0" indent="0">
               <a:buNone/>
             </a:pPr>
             <a:r>
@@ -9825,7 +9882,7 @@
           <a:bodyPr wrap="square" lIns="0" tIns="0" rIns="0" bIns="0" rtlCol="0" anchor="ctr"/>
           <a:lstStyle/>
           <a:p>
-            <a:pPr indent="0" marL="0">
+            <a:pPr marL="0" indent="0">
               <a:buNone/>
             </a:pPr>
             <a:r>
@@ -10144,4 +10201,319 @@
     </a:ext>
   </a:extLst>
 </a:theme>
+</file>
+
+<file path=ppt/theme/theme2.xml><?xml version="1.0" encoding="utf-8"?>
+<a:theme xmlns:a="http://schemas.openxmlformats.org/drawingml/2006/main" name="Office Theme">
+  <a:themeElements>
+    <a:clrScheme name="Office">
+      <a:dk1>
+        <a:sysClr val="windowText" lastClr="000000"/>
+      </a:dk1>
+      <a:lt1>
+        <a:sysClr val="window" lastClr="FFFFFF"/>
+      </a:lt1>
+      <a:dk2>
+        <a:srgbClr val="0E2841"/>
+      </a:dk2>
+      <a:lt2>
+        <a:srgbClr val="E8E8E8"/>
+      </a:lt2>
+      <a:accent1>
+        <a:srgbClr val="156082"/>
+      </a:accent1>
+      <a:accent2>
+        <a:srgbClr val="E97132"/>
+      </a:accent2>
+      <a:accent3>
+        <a:srgbClr val="196B24"/>
+      </a:accent3>
+      <a:accent4>
+        <a:srgbClr val="0F9ED5"/>
+      </a:accent4>
+      <a:accent5>
+        <a:srgbClr val="A02B93"/>
+      </a:accent5>
+      <a:accent6>
+        <a:srgbClr val="4EA72E"/>
+      </a:accent6>
+      <a:hlink>
+        <a:srgbClr val="467886"/>
+      </a:hlink>
+      <a:folHlink>
+        <a:srgbClr val="96607D"/>
+      </a:folHlink>
+    </a:clrScheme>
+    <a:fontScheme name="Office">
+      <a:majorFont>
+        <a:latin typeface="Aptos Display" panose="02110004020202020204"/>
+        <a:ea typeface=""/>
+        <a:cs typeface=""/>
+        <a:font script="Jpan" typeface="游ゴシック Light"/>
+        <a:font script="Hang" typeface="맑은 고딕"/>
+        <a:font script="Hans" typeface="等线 Light"/>
+        <a:font script="Hant" typeface="新細明體"/>
+        <a:font script="Arab" typeface="Times New Roman"/>
+        <a:font script="Hebr" typeface="Times New Roman"/>
+        <a:font script="Thai" typeface="Angsana New"/>
+        <a:font script="Ethi" typeface="Nyala"/>
+        <a:font script="Beng" typeface="Vrinda"/>
+        <a:font script="Gujr" typeface="Shruti"/>
+        <a:font script="Khmr" typeface="MoolBoran"/>
+        <a:font script="Knda" typeface="Tunga"/>
+        <a:font script="Guru" typeface="Raavi"/>
+        <a:font script="Cans" typeface="Euphemia"/>
+        <a:font script="Cher" typeface="Plantagenet Cherokee"/>
+        <a:font script="Yiii" typeface="Microsoft Yi Baiti"/>
+        <a:font script="Tibt" typeface="Microsoft Himalaya"/>
+        <a:font script="Thaa" typeface="MV Boli"/>
+        <a:font script="Deva" typeface="Mangal"/>
+        <a:font script="Telu" typeface="Gautami"/>
+        <a:font script="Taml" typeface="Latha"/>
+        <a:font script="Syrc" typeface="Estrangelo Edessa"/>
+        <a:font script="Orya" typeface="Kalinga"/>
+        <a:font script="Mlym" typeface="Kartika"/>
+        <a:font script="Laoo" typeface="DokChampa"/>
+        <a:font script="Sinh" typeface="Iskoola Pota"/>
+        <a:font script="Mong" typeface="Mongolian Baiti"/>
+        <a:font script="Viet" typeface="Times New Roman"/>
+        <a:font script="Uigh" typeface="Microsoft Uighur"/>
+        <a:font script="Geor" typeface="Sylfaen"/>
+        <a:font script="Armn" typeface="Arial"/>
+        <a:font script="Bugi" typeface="Leelawadee UI"/>
+        <a:font script="Bopo" typeface="Microsoft JhengHei"/>
+        <a:font script="Java" typeface="Javanese Text"/>
+        <a:font script="Lisu" typeface="Segoe UI"/>
+        <a:font script="Mymr" typeface="Myanmar Text"/>
+        <a:font script="Nkoo" typeface="Ebrima"/>
+        <a:font script="Olck" typeface="Nirmala UI"/>
+        <a:font script="Osma" typeface="Ebrima"/>
+        <a:font script="Phag" typeface="Phagspa"/>
+        <a:font script="Syrn" typeface="Estrangelo Edessa"/>
+        <a:font script="Syrj" typeface="Estrangelo Edessa"/>
+        <a:font script="Syre" typeface="Estrangelo Edessa"/>
+        <a:font script="Sora" typeface="Nirmala UI"/>
+        <a:font script="Tale" typeface="Microsoft Tai Le"/>
+        <a:font script="Talu" typeface="Microsoft New Tai Lue"/>
+        <a:font script="Tfng" typeface="Ebrima"/>
+      </a:majorFont>
+      <a:minorFont>
+        <a:latin typeface="Aptos" panose="02110004020202020204"/>
+        <a:ea typeface=""/>
+        <a:cs typeface=""/>
+        <a:font script="Jpan" typeface="游ゴシック"/>
+        <a:font script="Hang" typeface="맑은 고딕"/>
+        <a:font script="Hans" typeface="等线"/>
+        <a:font script="Hant" typeface="新細明體"/>
+        <a:font script="Arab" typeface="Arial"/>
+        <a:font script="Hebr" typeface="Arial"/>
+        <a:font script="Thai" typeface="Cordia New"/>
+        <a:font script="Ethi" typeface="Nyala"/>
+        <a:font script="Beng" typeface="Vrinda"/>
+        <a:font script="Gujr" typeface="Shruti"/>
+        <a:font script="Khmr" typeface="DaunPenh"/>
+        <a:font script="Knda" typeface="Tunga"/>
+        <a:font script="Guru" typeface="Raavi"/>
+        <a:font script="Cans" typeface="Euphemia"/>
+        <a:font script="Cher" typeface="Plantagenet Cherokee"/>
+        <a:font script="Yiii" typeface="Microsoft Yi Baiti"/>
+        <a:font script="Tibt" typeface="Microsoft Himalaya"/>
+        <a:font script="Thaa" typeface="MV Boli"/>
+        <a:font script="Deva" typeface="Mangal"/>
+        <a:font script="Telu" typeface="Gautami"/>
+        <a:font script="Taml" typeface="Latha"/>
+        <a:font script="Syrc" typeface="Estrangelo Edessa"/>
+        <a:font script="Orya" typeface="Kalinga"/>
+        <a:font script="Mlym" typeface="Kartika"/>
+        <a:font script="Laoo" typeface="DokChampa"/>
+        <a:font script="Sinh" typeface="Iskoola Pota"/>
+        <a:font script="Mong" typeface="Mongolian Baiti"/>
+        <a:font script="Viet" typeface="Arial"/>
+        <a:font script="Uigh" typeface="Microsoft Uighur"/>
+        <a:font script="Geor" typeface="Sylfaen"/>
+        <a:font script="Armn" typeface="Arial"/>
+        <a:font script="Bugi" typeface="Leelawadee UI"/>
+        <a:font script="Bopo" typeface="Microsoft JhengHei"/>
+        <a:font script="Java" typeface="Javanese Text"/>
+        <a:font script="Lisu" typeface="Segoe UI"/>
+        <a:font script="Mymr" typeface="Myanmar Text"/>
+        <a:font script="Nkoo" typeface="Ebrima"/>
+        <a:font script="Olck" typeface="Nirmala UI"/>
+        <a:font script="Osma" typeface="Ebrima"/>
+        <a:font script="Phag" typeface="Phagspa"/>
+        <a:font script="Syrn" typeface="Estrangelo Edessa"/>
+        <a:font script="Syrj" typeface="Estrangelo Edessa"/>
+        <a:font script="Syre" typeface="Estrangelo Edessa"/>
+        <a:font script="Sora" typeface="Nirmala UI"/>
+        <a:font script="Tale" typeface="Microsoft Tai Le"/>
+        <a:font script="Talu" typeface="Microsoft New Tai Lue"/>
+        <a:font script="Tfng" typeface="Ebrima"/>
+      </a:minorFont>
+    </a:fontScheme>
+    <a:fmtScheme name="Office">
+      <a:fillStyleLst>
+        <a:solidFill>
+          <a:schemeClr val="phClr"/>
+        </a:solidFill>
+        <a:gradFill rotWithShape="1">
+          <a:gsLst>
+            <a:gs pos="0">
+              <a:schemeClr val="phClr">
+                <a:lumMod val="110000"/>
+                <a:satMod val="105000"/>
+                <a:tint val="67000"/>
+              </a:schemeClr>
+            </a:gs>
+            <a:gs pos="50000">
+              <a:schemeClr val="phClr">
+                <a:lumMod val="105000"/>
+                <a:satMod val="103000"/>
+                <a:tint val="73000"/>
+              </a:schemeClr>
+            </a:gs>
+            <a:gs pos="100000">
+              <a:schemeClr val="phClr">
+                <a:lumMod val="105000"/>
+                <a:satMod val="109000"/>
+                <a:tint val="81000"/>
+              </a:schemeClr>
+            </a:gs>
+          </a:gsLst>
+          <a:lin ang="5400000" scaled="0"/>
+        </a:gradFill>
+        <a:gradFill rotWithShape="1">
+          <a:gsLst>
+            <a:gs pos="0">
+              <a:schemeClr val="phClr">
+                <a:satMod val="103000"/>
+                <a:lumMod val="102000"/>
+                <a:tint val="94000"/>
+              </a:schemeClr>
+            </a:gs>
+            <a:gs pos="50000">
+              <a:schemeClr val="phClr">
+                <a:satMod val="110000"/>
+                <a:lumMod val="100000"/>
+                <a:shade val="100000"/>
+              </a:schemeClr>
+            </a:gs>
+            <a:gs pos="100000">
+              <a:schemeClr val="phClr">
+                <a:lumMod val="99000"/>
+                <a:satMod val="120000"/>
+                <a:shade val="78000"/>
+              </a:schemeClr>
+            </a:gs>
+          </a:gsLst>
+          <a:lin ang="5400000" scaled="0"/>
+        </a:gradFill>
+      </a:fillStyleLst>
+      <a:lnStyleLst>
+        <a:ln w="12700" cap="flat" cmpd="sng" algn="ctr">
+          <a:solidFill>
+            <a:schemeClr val="phClr"/>
+          </a:solidFill>
+          <a:prstDash val="solid"/>
+          <a:miter lim="800000"/>
+        </a:ln>
+        <a:ln w="19050" cap="flat" cmpd="sng" algn="ctr">
+          <a:solidFill>
+            <a:schemeClr val="phClr"/>
+          </a:solidFill>
+          <a:prstDash val="solid"/>
+          <a:miter lim="800000"/>
+        </a:ln>
+        <a:ln w="25400" cap="flat" cmpd="sng" algn="ctr">
+          <a:solidFill>
+            <a:schemeClr val="phClr"/>
+          </a:solidFill>
+          <a:prstDash val="solid"/>
+          <a:miter lim="800000"/>
+        </a:ln>
+      </a:lnStyleLst>
+      <a:effectStyleLst>
+        <a:effectStyle>
+          <a:effectLst/>
+        </a:effectStyle>
+        <a:effectStyle>
+          <a:effectLst/>
+        </a:effectStyle>
+        <a:effectStyle>
+          <a:effectLst>
+            <a:outerShdw blurRad="57150" dist="19050" dir="5400000" algn="ctr" rotWithShape="0">
+              <a:srgbClr val="000000">
+                <a:alpha val="63000"/>
+              </a:srgbClr>
+            </a:outerShdw>
+          </a:effectLst>
+        </a:effectStyle>
+      </a:effectStyleLst>
+      <a:bgFillStyleLst>
+        <a:solidFill>
+          <a:schemeClr val="phClr"/>
+        </a:solidFill>
+        <a:solidFill>
+          <a:schemeClr val="phClr">
+            <a:tint val="95000"/>
+            <a:satMod val="170000"/>
+          </a:schemeClr>
+        </a:solidFill>
+        <a:gradFill rotWithShape="1">
+          <a:gsLst>
+            <a:gs pos="0">
+              <a:schemeClr val="phClr">
+                <a:tint val="93000"/>
+                <a:satMod val="150000"/>
+                <a:shade val="98000"/>
+                <a:lumMod val="102000"/>
+              </a:schemeClr>
+            </a:gs>
+            <a:gs pos="50000">
+              <a:schemeClr val="phClr">
+                <a:tint val="98000"/>
+                <a:satMod val="130000"/>
+                <a:shade val="90000"/>
+                <a:lumMod val="103000"/>
+              </a:schemeClr>
+            </a:gs>
+            <a:gs pos="100000">
+              <a:schemeClr val="phClr">
+                <a:shade val="63000"/>
+                <a:satMod val="120000"/>
+              </a:schemeClr>
+            </a:gs>
+          </a:gsLst>
+          <a:lin ang="5400000" scaled="0"/>
+        </a:gradFill>
+      </a:bgFillStyleLst>
+    </a:fmtScheme>
+  </a:themeElements>
+  <a:objectDefaults>
+    <a:lnDef>
+      <a:spPr/>
+      <a:bodyPr/>
+      <a:lstStyle/>
+      <a:style>
+        <a:lnRef idx="2">
+          <a:schemeClr val="accent1"/>
+        </a:lnRef>
+        <a:fillRef idx="0">
+          <a:schemeClr val="accent1"/>
+        </a:fillRef>
+        <a:effectRef idx="1">
+          <a:schemeClr val="accent1"/>
+        </a:effectRef>
+        <a:fontRef idx="minor">
+          <a:schemeClr val="tx1"/>
+        </a:fontRef>
+      </a:style>
+    </a:lnDef>
+  </a:objectDefaults>
+  <a:extraClrSchemeLst/>
+  <a:extLst>
+    <a:ext uri="{05A4C25C-085E-4340-85A3-A5531E510DB2}">
+      <thm15:themeFamily xmlns:thm15="http://schemas.microsoft.com/office/thememl/2012/main" name="Office Theme" id="{2E142A2C-CD16-42D6-873A-C26D2A0506FA}" vid="{1BDDFF52-6CD6-40A5-AB3C-68EB2F1E4D0A}"/>
+    </a:ext>
+  </a:extLst>
+</a:theme>
 </file>
</xml_diff>